<commit_message>
Fix save crash on empty BGA stage; publish feature; README; cleanup
</commit_message>
<xml_diff>
--- a/00_시뮬레이션 도입.pptx
+++ b/00_시뮬레이션 도입.pptx
@@ -8,17 +8,17 @@
     <p:notesMasterId r:id="rId25"/>
   </p:notesMasterIdLst>
   <p:sldIdLst>
-    <p:sldId id="274" r:id="rId2"/>
-    <p:sldId id="275" r:id="rId3"/>
-    <p:sldId id="276" r:id="rId4"/>
-    <p:sldId id="281" r:id="rId5"/>
-    <p:sldId id="278" r:id="rId6"/>
-    <p:sldId id="279" r:id="rId7"/>
-    <p:sldId id="262" r:id="rId8"/>
-    <p:sldId id="263" r:id="rId9"/>
-    <p:sldId id="264" r:id="rId10"/>
-    <p:sldId id="266" r:id="rId11"/>
-    <p:sldId id="267" r:id="rId12"/>
+    <p:sldId id="262" r:id="rId2"/>
+    <p:sldId id="263" r:id="rId3"/>
+    <p:sldId id="264" r:id="rId4"/>
+    <p:sldId id="266" r:id="rId5"/>
+    <p:sldId id="267" r:id="rId6"/>
+    <p:sldId id="274" r:id="rId7"/>
+    <p:sldId id="275" r:id="rId8"/>
+    <p:sldId id="276" r:id="rId9"/>
+    <p:sldId id="281" r:id="rId10"/>
+    <p:sldId id="278" r:id="rId11"/>
+    <p:sldId id="279" r:id="rId12"/>
     <p:sldId id="268" r:id="rId13"/>
     <p:sldId id="269" r:id="rId14"/>
     <p:sldId id="282" r:id="rId15"/>
@@ -1925,13 +1925,7 @@
   <p:cSld>
     <p:spTree>
       <p:nvGrpSpPr>
-        <p:cNvPr id="1" name="">
-          <a:extLst>
-            <a:ext uri="{FF2B5EF4-FFF2-40B4-BE49-F238E27FC236}">
-              <a16:creationId xmlns:a16="http://schemas.microsoft.com/office/drawing/2014/main" id="{F2ACE80F-0142-DDDB-F950-0E6E3DBE77E9}"/>
-            </a:ext>
-          </a:extLst>
-        </p:cNvPr>
+        <p:cNvPr id="1" name=""/>
         <p:cNvGrpSpPr/>
         <p:nvPr/>
       </p:nvGrpSpPr>
@@ -1945,13 +1939,7 @@
       </p:grpSpPr>
       <p:sp>
         <p:nvSpPr>
-          <p:cNvPr id="2" name="Slide Image Placeholder 1">
-            <a:extLst>
-              <a:ext uri="{FF2B5EF4-FFF2-40B4-BE49-F238E27FC236}">
-                <a16:creationId xmlns:a16="http://schemas.microsoft.com/office/drawing/2014/main" id="{CF9747D0-90B0-9027-6E29-620248EF0A8B}"/>
-              </a:ext>
-            </a:extLst>
-          </p:cNvPr>
+          <p:cNvPr id="2" name="Slide Image Placeholder 1"/>
           <p:cNvSpPr>
             <a:spLocks noGrp="1" noRot="1" noChangeAspect="1"/>
           </p:cNvSpPr>
@@ -1963,13 +1951,7 @@
       </p:sp>
       <p:sp>
         <p:nvSpPr>
-          <p:cNvPr id="3" name="Notes Placeholder 2">
-            <a:extLst>
-              <a:ext uri="{FF2B5EF4-FFF2-40B4-BE49-F238E27FC236}">
-                <a16:creationId xmlns:a16="http://schemas.microsoft.com/office/drawing/2014/main" id="{F1232031-41CE-668F-32AB-16B6CEDD2C66}"/>
-              </a:ext>
-            </a:extLst>
-          </p:cNvPr>
+          <p:cNvPr id="3" name="Notes Placeholder 2"/>
           <p:cNvSpPr>
             <a:spLocks noGrp="1"/>
           </p:cNvSpPr>
@@ -1988,13 +1970,7 @@
       </p:sp>
       <p:sp>
         <p:nvSpPr>
-          <p:cNvPr id="4" name="Slide Number Placeholder 3">
-            <a:extLst>
-              <a:ext uri="{FF2B5EF4-FFF2-40B4-BE49-F238E27FC236}">
-                <a16:creationId xmlns:a16="http://schemas.microsoft.com/office/drawing/2014/main" id="{7D064420-B712-F02F-FF49-2B3912C8615E}"/>
-              </a:ext>
-            </a:extLst>
-          </p:cNvPr>
+          <p:cNvPr id="4" name="Slide Number Placeholder 3"/>
           <p:cNvSpPr>
             <a:spLocks noGrp="1"/>
           </p:cNvSpPr>
@@ -2018,7 +1994,7 @@
     </p:spTree>
     <p:extLst>
       <p:ext uri="{BB962C8B-B14F-4D97-AF65-F5344CB8AC3E}">
-        <p14:creationId xmlns:p14="http://schemas.microsoft.com/office/powerpoint/2010/main" val="4059808561"/>
+        <p14:creationId xmlns:p14="http://schemas.microsoft.com/office/powerpoint/2010/main" val="1024086991"/>
       </p:ext>
     </p:extLst>
   </p:cSld>
@@ -2369,7 +2345,13 @@
   <p:cSld>
     <p:spTree>
       <p:nvGrpSpPr>
-        <p:cNvPr id="1" name=""/>
+        <p:cNvPr id="1" name="">
+          <a:extLst>
+            <a:ext uri="{FF2B5EF4-FFF2-40B4-BE49-F238E27FC236}">
+              <a16:creationId xmlns:a16="http://schemas.microsoft.com/office/drawing/2014/main" id="{F2ACE80F-0142-DDDB-F950-0E6E3DBE77E9}"/>
+            </a:ext>
+          </a:extLst>
+        </p:cNvPr>
         <p:cNvGrpSpPr/>
         <p:nvPr/>
       </p:nvGrpSpPr>
@@ -2383,7 +2365,13 @@
       </p:grpSpPr>
       <p:sp>
         <p:nvSpPr>
-          <p:cNvPr id="2" name="Slide Image Placeholder 1"/>
+          <p:cNvPr id="2" name="Slide Image Placeholder 1">
+            <a:extLst>
+              <a:ext uri="{FF2B5EF4-FFF2-40B4-BE49-F238E27FC236}">
+                <a16:creationId xmlns:a16="http://schemas.microsoft.com/office/drawing/2014/main" id="{CF9747D0-90B0-9027-6E29-620248EF0A8B}"/>
+              </a:ext>
+            </a:extLst>
+          </p:cNvPr>
           <p:cNvSpPr>
             <a:spLocks noGrp="1" noRot="1" noChangeAspect="1"/>
           </p:cNvSpPr>
@@ -2395,7 +2383,13 @@
       </p:sp>
       <p:sp>
         <p:nvSpPr>
-          <p:cNvPr id="3" name="Notes Placeholder 2"/>
+          <p:cNvPr id="3" name="Notes Placeholder 2">
+            <a:extLst>
+              <a:ext uri="{FF2B5EF4-FFF2-40B4-BE49-F238E27FC236}">
+                <a16:creationId xmlns:a16="http://schemas.microsoft.com/office/drawing/2014/main" id="{F1232031-41CE-668F-32AB-16B6CEDD2C66}"/>
+              </a:ext>
+            </a:extLst>
+          </p:cNvPr>
           <p:cNvSpPr>
             <a:spLocks noGrp="1"/>
           </p:cNvSpPr>
@@ -2414,7 +2408,13 @@
       </p:sp>
       <p:sp>
         <p:nvSpPr>
-          <p:cNvPr id="4" name="Slide Number Placeholder 3"/>
+          <p:cNvPr id="4" name="Slide Number Placeholder 3">
+            <a:extLst>
+              <a:ext uri="{FF2B5EF4-FFF2-40B4-BE49-F238E27FC236}">
+                <a16:creationId xmlns:a16="http://schemas.microsoft.com/office/drawing/2014/main" id="{7D064420-B712-F02F-FF49-2B3912C8615E}"/>
+              </a:ext>
+            </a:extLst>
+          </p:cNvPr>
           <p:cNvSpPr>
             <a:spLocks noGrp="1"/>
           </p:cNvSpPr>
@@ -2438,7 +2438,7 @@
     </p:spTree>
     <p:extLst>
       <p:ext uri="{BB962C8B-B14F-4D97-AF65-F5344CB8AC3E}">
-        <p14:creationId xmlns:p14="http://schemas.microsoft.com/office/powerpoint/2010/main" val="1024086991"/>
+        <p14:creationId xmlns:p14="http://schemas.microsoft.com/office/powerpoint/2010/main" val="4059808561"/>
       </p:ext>
     </p:extLst>
   </p:cSld>
@@ -2762,11 +2762,11 @@
 
 <file path=ppt/slides/slide1.xml><?xml version="1.0" encoding="utf-8"?>
 <p:sld xmlns:a="http://schemas.openxmlformats.org/drawingml/2006/main" xmlns:r="http://schemas.openxmlformats.org/officeDocument/2006/relationships" xmlns:p="http://schemas.openxmlformats.org/presentationml/2006/main">
-  <p:cSld name="Slide 19">
+  <p:cSld name="Slide 7">
     <p:bg>
       <p:bgPr>
         <a:solidFill>
-          <a:srgbClr val="3A0A22"/>
+          <a:srgbClr val="3D1509"/>
         </a:solidFill>
         <a:effectLst/>
       </p:bgPr>
@@ -2908,7 +2908,7 @@
             <a:r>
               <a:rPr lang="en-US" sz="1400" b="1" kern="0" spc="300" dirty="0" err="1">
                 <a:solidFill>
-                  <a:srgbClr val="E9B8CB"/>
+                  <a:srgbClr val="F0C4AE"/>
                 </a:solidFill>
                 <a:latin typeface="Calibri" pitchFamily="34" charset="0"/>
                 <a:ea typeface="Calibri" pitchFamily="34" charset="-122"/>
@@ -2930,11 +2930,11 @@
 
 <file path=ppt/slides/slide10.xml><?xml version="1.0" encoding="utf-8"?>
 <p:sld xmlns:a="http://schemas.openxmlformats.org/drawingml/2006/main" xmlns:r="http://schemas.openxmlformats.org/officeDocument/2006/relationships" xmlns:p="http://schemas.openxmlformats.org/presentationml/2006/main">
-  <p:cSld name="Slide 11">
+  <p:cSld name="Slide 23">
     <p:bg>
       <p:bgPr>
         <a:solidFill>
-          <a:srgbClr val="3D1509"/>
+          <a:srgbClr val="3A0A22"/>
         </a:solidFill>
         <a:effectLst/>
       </p:bgPr>
@@ -2961,8 +2961,8 @@
         </p:nvSpPr>
         <p:spPr>
           <a:xfrm>
-            <a:off x="1280160" y="1296785"/>
-            <a:ext cx="9631375" cy="4488873"/>
+            <a:off x="1280160" y="2468880"/>
+            <a:ext cx="9631375" cy="1920240"/>
           </a:xfrm>
           <a:prstGeom prst="rect">
             <a:avLst/>
@@ -2981,61 +2981,6 @@
               <a:buNone/>
             </a:pPr>
             <a:r>
-              <a:rPr lang="en-US" sz="2600" i="1" dirty="0" err="1">
-                <a:solidFill>
-                  <a:srgbClr val="FFFFFF"/>
-                </a:solidFill>
-                <a:latin typeface="Cambria" pitchFamily="34" charset="0"/>
-                <a:ea typeface="Cambria" pitchFamily="34" charset="-122"/>
-                <a:cs typeface="Cambria" pitchFamily="34" charset="-120"/>
-              </a:rPr>
-              <a:t>최대한</a:t>
-            </a:r>
-            <a:r>
-              <a:rPr lang="ko-KR" altLang="en-US" sz="2600" i="1" dirty="0">
-                <a:solidFill>
-                  <a:srgbClr val="FFFFFF"/>
-                </a:solidFill>
-                <a:latin typeface="Cambria" pitchFamily="34" charset="0"/>
-                <a:ea typeface="Cambria" pitchFamily="34" charset="-122"/>
-                <a:cs typeface="Cambria" pitchFamily="34" charset="-120"/>
-              </a:rPr>
-              <a:t> 빨리 이송해달라고 답변하고 전화를 </a:t>
-            </a:r>
-            <a:r>
-              <a:rPr lang="ko-KR" altLang="en-US" sz="2600" i="1" dirty="0" err="1">
-                <a:solidFill>
-                  <a:srgbClr val="FFFFFF"/>
-                </a:solidFill>
-                <a:latin typeface="Cambria" pitchFamily="34" charset="0"/>
-                <a:ea typeface="Cambria" pitchFamily="34" charset="-122"/>
-                <a:cs typeface="Cambria" pitchFamily="34" charset="-120"/>
-              </a:rPr>
-              <a:t>끊은지</a:t>
-            </a:r>
-            <a:r>
-              <a:rPr lang="ko-KR" altLang="en-US" sz="2600" i="1" dirty="0">
-                <a:solidFill>
-                  <a:srgbClr val="FFFFFF"/>
-                </a:solidFill>
-                <a:latin typeface="Cambria" pitchFamily="34" charset="0"/>
-                <a:ea typeface="Cambria" pitchFamily="34" charset="-122"/>
-                <a:cs typeface="Cambria" pitchFamily="34" charset="-120"/>
-              </a:rPr>
-              <a:t> 얼마 되지 않아</a:t>
-            </a:r>
-            <a:r>
-              <a:rPr lang="en-US" sz="2600" i="1" dirty="0" err="1">
-                <a:solidFill>
-                  <a:srgbClr val="FFFFFF"/>
-                </a:solidFill>
-                <a:latin typeface="Cambria" pitchFamily="34" charset="0"/>
-                <a:ea typeface="Cambria" pitchFamily="34" charset="-122"/>
-                <a:cs typeface="Cambria" pitchFamily="34" charset="-120"/>
-              </a:rPr>
-              <a:t>사이렌</a:t>
-            </a:r>
-            <a:r>
               <a:rPr lang="en-US" sz="2600" i="1" dirty="0">
                 <a:solidFill>
                   <a:srgbClr val="FFFFFF"/>
@@ -3044,123 +2989,9 @@
                 <a:ea typeface="Cambria" pitchFamily="34" charset="-122"/>
                 <a:cs typeface="Cambria" pitchFamily="34" charset="-120"/>
               </a:rPr>
-              <a:t> </a:t>
-            </a:r>
-            <a:r>
-              <a:rPr lang="en-US" sz="2600" i="1" dirty="0" err="1">
-                <a:solidFill>
-                  <a:srgbClr val="FFFFFF"/>
-                </a:solidFill>
-                <a:latin typeface="Cambria" pitchFamily="34" charset="0"/>
-                <a:ea typeface="Cambria" pitchFamily="34" charset="-122"/>
-                <a:cs typeface="Cambria" pitchFamily="34" charset="-120"/>
-              </a:rPr>
-              <a:t>소리가</a:t>
-            </a:r>
-            <a:r>
-              <a:rPr lang="en-US" sz="2600" i="1" dirty="0">
-                <a:solidFill>
-                  <a:srgbClr val="FFFFFF"/>
-                </a:solidFill>
-                <a:latin typeface="Cambria" pitchFamily="34" charset="0"/>
-                <a:ea typeface="Cambria" pitchFamily="34" charset="-122"/>
-                <a:cs typeface="Cambria" pitchFamily="34" charset="-120"/>
-              </a:rPr>
-              <a:t> </a:t>
-            </a:r>
-            <a:r>
-              <a:rPr lang="en-US" sz="2600" i="1" dirty="0" err="1">
-                <a:solidFill>
-                  <a:srgbClr val="FFFFFF"/>
-                </a:solidFill>
-                <a:latin typeface="Cambria" pitchFamily="34" charset="0"/>
-                <a:ea typeface="Cambria" pitchFamily="34" charset="-122"/>
-                <a:cs typeface="Cambria" pitchFamily="34" charset="-120"/>
-              </a:rPr>
-              <a:t>들리기</a:t>
-            </a:r>
-            <a:r>
-              <a:rPr lang="ko-KR" altLang="en-US" sz="2600" i="1" dirty="0">
-                <a:solidFill>
-                  <a:srgbClr val="FFFFFF"/>
-                </a:solidFill>
-                <a:latin typeface="Cambria" pitchFamily="34" charset="0"/>
-                <a:ea typeface="Cambria" pitchFamily="34" charset="-122"/>
-                <a:cs typeface="Cambria" pitchFamily="34" charset="-120"/>
-              </a:rPr>
-              <a:t> 시작한다</a:t>
-            </a:r>
-            <a:r>
-              <a:rPr lang="en-US" sz="2600" i="1" dirty="0">
-                <a:solidFill>
-                  <a:srgbClr val="FFFFFF"/>
-                </a:solidFill>
-                <a:latin typeface="Cambria" pitchFamily="34" charset="0"/>
-                <a:ea typeface="Cambria" pitchFamily="34" charset="-122"/>
-                <a:cs typeface="Cambria" pitchFamily="34" charset="-120"/>
-              </a:rPr>
-              <a:t>. </a:t>
-            </a:r>
-          </a:p>
-          <a:p>
-            <a:pPr marL="0" indent="0" algn="ctr">
-              <a:lnSpc>
-                <a:spcPct val="135000"/>
-              </a:lnSpc>
-              <a:buNone/>
-            </a:pPr>
-            <a:r>
-              <a:rPr lang="en-US" sz="2600" i="1" dirty="0" err="1">
-                <a:solidFill>
-                  <a:srgbClr val="FFFFFF"/>
-                </a:solidFill>
-                <a:latin typeface="Cambria" pitchFamily="34" charset="0"/>
-                <a:ea typeface="Cambria" pitchFamily="34" charset="-122"/>
-                <a:cs typeface="Cambria" pitchFamily="34" charset="-120"/>
-              </a:rPr>
-              <a:t>처치실에</a:t>
-            </a:r>
-            <a:r>
-              <a:rPr lang="ko-KR" altLang="en-US" sz="2600" i="1" dirty="0">
-                <a:solidFill>
-                  <a:srgbClr val="FFFFFF"/>
-                </a:solidFill>
-                <a:latin typeface="Cambria" pitchFamily="34" charset="0"/>
-                <a:ea typeface="Cambria" pitchFamily="34" charset="-122"/>
-                <a:cs typeface="Cambria" pitchFamily="34" charset="-120"/>
-              </a:rPr>
-              <a:t> 환자 받는 준비로 어수선하다</a:t>
-            </a:r>
-            <a:r>
-              <a:rPr lang="en-US" altLang="ko-KR" sz="2600" i="1" dirty="0">
-                <a:solidFill>
-                  <a:srgbClr val="FFFFFF"/>
-                </a:solidFill>
-                <a:latin typeface="Cambria" pitchFamily="34" charset="0"/>
-                <a:ea typeface="Cambria" pitchFamily="34" charset="-122"/>
-                <a:cs typeface="Cambria" pitchFamily="34" charset="-120"/>
-              </a:rPr>
-              <a:t>.</a:t>
-            </a:r>
-            <a:r>
-              <a:rPr lang="ko-KR" altLang="en-US" sz="2600" i="1" dirty="0">
-                <a:solidFill>
-                  <a:srgbClr val="FFFFFF"/>
-                </a:solidFill>
-                <a:latin typeface="Cambria" pitchFamily="34" charset="0"/>
-                <a:ea typeface="Cambria" pitchFamily="34" charset="-122"/>
-                <a:cs typeface="Cambria" pitchFamily="34" charset="-120"/>
-              </a:rPr>
-              <a:t> </a:t>
-            </a:r>
-            <a:endParaRPr lang="en-US" altLang="ko-KR" sz="2600" i="1" dirty="0">
-              <a:solidFill>
-                <a:srgbClr val="FFFFFF"/>
-              </a:solidFill>
-              <a:latin typeface="Cambria" pitchFamily="34" charset="0"/>
-              <a:ea typeface="Cambria" pitchFamily="34" charset="-122"/>
-              <a:cs typeface="Cambria" pitchFamily="34" charset="-120"/>
-            </a:endParaRPr>
+              <a:t>처치실로 들어서자 아이는 침대에 늘어져 있다. 평소라면 낯선 사람을 보고 울었을 아이지만, 지금은 눈을 뜨는 것조차 힘겨워 보인다.</a:t>
+            </a:r>
+            <a:endParaRPr lang="en-US" sz="2600" dirty="0"/>
           </a:p>
           <a:p>
             <a:pPr marL="0" indent="0" algn="ctr">
@@ -3187,8 +3018,16 @@
                 <a:ea typeface="Cambria" pitchFamily="34" charset="-122"/>
                 <a:cs typeface="Cambria" pitchFamily="34" charset="-120"/>
               </a:rPr>
-              <a:t>심상치 않은 손상 기전을 직감한 당신은 곧바로 치프 </a:t>
-            </a:r>
+              <a:t>항암치료 중이라는 병력이 머릿속에 경고음을 울리고, </a:t>
+            </a:r>
+          </a:p>
+          <a:p>
+            <a:pPr marL="0" indent="0" algn="ctr">
+              <a:lnSpc>
+                <a:spcPct val="135000"/>
+              </a:lnSpc>
+              <a:buNone/>
+            </a:pPr>
             <a:r>
               <a:rPr lang="en-US" sz="2600" i="1" dirty="0" err="1">
                 <a:solidFill>
@@ -3198,6 +3037,28 @@
                 <a:ea typeface="Cambria" pitchFamily="34" charset="-122"/>
                 <a:cs typeface="Cambria" pitchFamily="34" charset="-120"/>
               </a:rPr>
+              <a:t>당신은</a:t>
+            </a:r>
+            <a:r>
+              <a:rPr lang="en-US" sz="2600" i="1" dirty="0">
+                <a:solidFill>
+                  <a:srgbClr val="FFFFFF"/>
+                </a:solidFill>
+                <a:latin typeface="Cambria" pitchFamily="34" charset="0"/>
+                <a:ea typeface="Cambria" pitchFamily="34" charset="-122"/>
+                <a:cs typeface="Cambria" pitchFamily="34" charset="-120"/>
+              </a:rPr>
+              <a:t> 곧바로 치프 </a:t>
+            </a:r>
+            <a:r>
+              <a:rPr lang="en-US" sz="2600" i="1" dirty="0" err="1">
+                <a:solidFill>
+                  <a:srgbClr val="FFFFFF"/>
+                </a:solidFill>
+                <a:latin typeface="Cambria" pitchFamily="34" charset="0"/>
+                <a:ea typeface="Cambria" pitchFamily="34" charset="-122"/>
+                <a:cs typeface="Cambria" pitchFamily="34" charset="-120"/>
+              </a:rPr>
               <a:t>당직과</a:t>
             </a:r>
             <a:r>
@@ -3220,7 +3081,29 @@
                 <a:ea typeface="Cambria" pitchFamily="34" charset="-122"/>
                 <a:cs typeface="Cambria" pitchFamily="34" charset="-120"/>
               </a:rPr>
-              <a:t>중환자실당직에게</a:t>
+              <a:t>중환자실</a:t>
+            </a:r>
+            <a:r>
+              <a:rPr lang="ko-KR" altLang="en-US" sz="2600" i="1" dirty="0">
+                <a:solidFill>
+                  <a:srgbClr val="FFFFFF"/>
+                </a:solidFill>
+                <a:latin typeface="Cambria" pitchFamily="34" charset="0"/>
+                <a:ea typeface="Cambria" pitchFamily="34" charset="-122"/>
+                <a:cs typeface="Cambria" pitchFamily="34" charset="-120"/>
+              </a:rPr>
+              <a:t> </a:t>
+            </a:r>
+            <a:r>
+              <a:rPr lang="en-US" sz="2600" i="1" dirty="0" err="1">
+                <a:solidFill>
+                  <a:srgbClr val="FFFFFF"/>
+                </a:solidFill>
+                <a:latin typeface="Cambria" pitchFamily="34" charset="0"/>
+                <a:ea typeface="Cambria" pitchFamily="34" charset="-122"/>
+                <a:cs typeface="Cambria" pitchFamily="34" charset="-120"/>
+              </a:rPr>
+              <a:t>당직을</a:t>
             </a:r>
             <a:r>
               <a:rPr lang="en-US" sz="2600" i="1" dirty="0">
@@ -3231,29 +3114,7 @@
                 <a:ea typeface="Cambria" pitchFamily="34" charset="-122"/>
                 <a:cs typeface="Cambria" pitchFamily="34" charset="-120"/>
               </a:rPr>
-              <a:t> </a:t>
-            </a:r>
-            <a:r>
-              <a:rPr lang="ko-KR" altLang="en-US" sz="2600" i="1" dirty="0">
-                <a:solidFill>
-                  <a:srgbClr val="FFFFFF"/>
-                </a:solidFill>
-                <a:latin typeface="Cambria" pitchFamily="34" charset="0"/>
-                <a:ea typeface="Cambria" pitchFamily="34" charset="-122"/>
-                <a:cs typeface="Cambria" pitchFamily="34" charset="-120"/>
-              </a:rPr>
-              <a:t> 상황을 알린다</a:t>
-            </a:r>
-            <a:r>
-              <a:rPr lang="en-US" sz="2600" i="1" dirty="0">
-                <a:solidFill>
-                  <a:srgbClr val="FFFFFF"/>
-                </a:solidFill>
-                <a:latin typeface="Cambria" pitchFamily="34" charset="0"/>
-                <a:ea typeface="Cambria" pitchFamily="34" charset="-122"/>
-                <a:cs typeface="Cambria" pitchFamily="34" charset="-120"/>
-              </a:rPr>
-              <a:t>. 팀이 모두 모인 순간, 환자가 도착한다.</a:t>
+              <a:t> 부른다.</a:t>
             </a:r>
             <a:endParaRPr lang="en-US" sz="2600" dirty="0"/>
           </a:p>
@@ -3264,16 +3125,24 @@
   <p:clrMapOvr>
     <a:masterClrMapping/>
   </p:clrMapOvr>
+  <mc:AlternateContent xmlns:mc="http://schemas.openxmlformats.org/markup-compatibility/2006">
+    <mc:Choice xmlns:p14="http://schemas.microsoft.com/office/powerpoint/2010/main" Requires="p14">
+      <p:transition spd="slow" p14:dur="2000" advTm="8638"/>
+    </mc:Choice>
+    <mc:Fallback>
+      <p:transition spd="slow" advTm="8638"/>
+    </mc:Fallback>
+  </mc:AlternateContent>
 </p:sld>
 </file>
 
 <file path=ppt/slides/slide11.xml><?xml version="1.0" encoding="utf-8"?>
 <p:sld xmlns:a="http://schemas.openxmlformats.org/drawingml/2006/main" xmlns:r="http://schemas.openxmlformats.org/officeDocument/2006/relationships" xmlns:p="http://schemas.openxmlformats.org/presentationml/2006/main">
-  <p:cSld name="Slide 12">
+  <p:cSld name="Slide 24">
     <p:bg>
       <p:bgPr>
         <a:solidFill>
-          <a:srgbClr val="C1440E"/>
+          <a:srgbClr val="9A1750"/>
         </a:solidFill>
         <a:effectLst/>
       </p:bgPr>
@@ -3352,7 +3221,7 @@
                 <a:ea typeface="Cambria" pitchFamily="34" charset="-122"/>
                 <a:cs typeface="Cambria" pitchFamily="34" charset="-120"/>
               </a:rPr>
-              <a:t> 다같이</a:t>
+              <a:t>함께 환자를 평가하고</a:t>
             </a:r>
             <a:endParaRPr lang="en-US" sz="3000" dirty="0"/>
           </a:p>
@@ -3372,7 +3241,7 @@
                 <a:ea typeface="Cambria" pitchFamily="34" charset="-122"/>
                 <a:cs typeface="Cambria" pitchFamily="34" charset="-120"/>
               </a:rPr>
-              <a:t>초기 평가와 처치 방침을 세우시오.</a:t>
+              <a:t>적절한 진단과 치료 방침을 세우시오.</a:t>
             </a:r>
             <a:endParaRPr lang="en-US" sz="3000" dirty="0"/>
           </a:p>
@@ -5152,11 +5021,11 @@
 
 <file path=ppt/slides/slide2.xml><?xml version="1.0" encoding="utf-8"?>
 <p:sld xmlns:a="http://schemas.openxmlformats.org/drawingml/2006/main" xmlns:r="http://schemas.openxmlformats.org/officeDocument/2006/relationships" xmlns:p="http://schemas.openxmlformats.org/presentationml/2006/main">
-  <p:cSld name="Slide 20">
+  <p:cSld name="Slide 8">
     <p:bg>
       <p:bgPr>
         <a:solidFill>
-          <a:srgbClr val="3A0A22"/>
+          <a:srgbClr val="3D1509"/>
         </a:solidFill>
         <a:effectLst/>
       </p:bgPr>
@@ -5196,21 +5065,22 @@
           <a:bodyPr wrap="square" lIns="0" tIns="0" rIns="0" bIns="0" rtlCol="0" anchor="ctr"/>
           <a:lstStyle/>
           <a:p>
-            <a:pPr algn="ctr">
+            <a:pPr marL="0" indent="0" algn="ctr">
               <a:lnSpc>
                 <a:spcPct val="135000"/>
               </a:lnSpc>
+              <a:buNone/>
             </a:pPr>
             <a:r>
-              <a:rPr lang="en-US" altLang="ko-KR" sz="2600" i="1" dirty="0" err="1">
-                <a:solidFill>
-                  <a:srgbClr val="FFFFFF"/>
-                </a:solidFill>
-                <a:latin typeface="Cambria" pitchFamily="34" charset="0"/>
-                <a:ea typeface="Cambria" pitchFamily="34" charset="-122"/>
-                <a:cs typeface="Cambria" pitchFamily="34" charset="-120"/>
-              </a:rPr>
-              <a:t>진료실</a:t>
+              <a:rPr lang="en-US" sz="2600" i="1" dirty="0" err="1">
+                <a:solidFill>
+                  <a:srgbClr val="FFFFFF"/>
+                </a:solidFill>
+                <a:latin typeface="Cambria" pitchFamily="34" charset="0"/>
+                <a:ea typeface="Cambria" pitchFamily="34" charset="-122"/>
+                <a:cs typeface="Cambria" pitchFamily="34" charset="-120"/>
+              </a:rPr>
+              <a:t>정적을</a:t>
             </a:r>
             <a:r>
               <a:rPr lang="ko-KR" altLang="en-US" sz="2600" i="1" dirty="0">
@@ -5221,29 +5091,7 @@
                 <a:ea typeface="Cambria" pitchFamily="34" charset="-122"/>
                 <a:cs typeface="Cambria" pitchFamily="34" charset="-120"/>
               </a:rPr>
-              <a:t> </a:t>
-            </a:r>
-            <a:r>
-              <a:rPr lang="en-US" altLang="ko-KR" sz="2600" i="1" dirty="0">
-                <a:solidFill>
-                  <a:srgbClr val="FFFFFF"/>
-                </a:solidFill>
-                <a:latin typeface="Cambria" pitchFamily="34" charset="0"/>
-                <a:ea typeface="Cambria" pitchFamily="34" charset="-122"/>
-                <a:cs typeface="Cambria" pitchFamily="34" charset="-120"/>
-              </a:rPr>
-              <a:t>2</a:t>
-            </a:r>
-            <a:r>
-              <a:rPr lang="ko-KR" altLang="en-US" sz="2600" i="1" dirty="0">
-                <a:solidFill>
-                  <a:srgbClr val="FFFFFF"/>
-                </a:solidFill>
-                <a:latin typeface="Cambria" pitchFamily="34" charset="0"/>
-                <a:ea typeface="Cambria" pitchFamily="34" charset="-122"/>
-                <a:cs typeface="Cambria" pitchFamily="34" charset="-120"/>
-              </a:rPr>
-              <a:t>번에서 졸린 눈을 </a:t>
+              <a:t> 깨는 전화벨소리 전화기 </a:t>
             </a:r>
             <a:r>
               <a:rPr lang="ko-KR" altLang="en-US" sz="2600" i="1" dirty="0" err="1">
@@ -5254,29 +5102,7 @@
                 <a:ea typeface="Cambria" pitchFamily="34" charset="-122"/>
                 <a:cs typeface="Cambria" pitchFamily="34" charset="-120"/>
               </a:rPr>
-              <a:t>부비고</a:t>
-            </a:r>
-            <a:r>
-              <a:rPr lang="ko-KR" altLang="en-US" sz="2600" i="1" dirty="0">
-                <a:solidFill>
-                  <a:srgbClr val="FFFFFF"/>
-                </a:solidFill>
-                <a:latin typeface="Cambria" pitchFamily="34" charset="0"/>
-                <a:ea typeface="Cambria" pitchFamily="34" charset="-122"/>
-                <a:cs typeface="Cambria" pitchFamily="34" charset="-120"/>
-              </a:rPr>
-              <a:t> 있을 때</a:t>
-            </a:r>
-            <a:r>
-              <a:rPr lang="en-US" altLang="ko-KR" sz="2600" i="1" dirty="0">
-                <a:solidFill>
-                  <a:srgbClr val="FFFFFF"/>
-                </a:solidFill>
-                <a:latin typeface="Cambria" pitchFamily="34" charset="0"/>
-                <a:ea typeface="Cambria" pitchFamily="34" charset="-122"/>
-                <a:cs typeface="Cambria" pitchFamily="34" charset="-120"/>
-              </a:rPr>
-              <a:t>,</a:t>
+              <a:t>넘어로</a:t>
             </a:r>
             <a:r>
               <a:rPr lang="ko-KR" altLang="en-US" sz="2600" i="1" dirty="0">
@@ -5306,28 +5132,6 @@
               <a:buNone/>
             </a:pPr>
             <a:r>
-              <a:rPr lang="ko-KR" altLang="en-US" sz="2600" i="1" dirty="0">
-                <a:solidFill>
-                  <a:srgbClr val="FFFFFF"/>
-                </a:solidFill>
-                <a:latin typeface="Cambria" pitchFamily="34" charset="0"/>
-                <a:ea typeface="Cambria" pitchFamily="34" charset="-122"/>
-                <a:cs typeface="Cambria" pitchFamily="34" charset="-120"/>
-              </a:rPr>
-              <a:t> </a:t>
-            </a:r>
-            <a:r>
-              <a:rPr lang="en-US" sz="2600" i="1" dirty="0" err="1">
-                <a:solidFill>
-                  <a:srgbClr val="FFFFFF"/>
-                </a:solidFill>
-                <a:latin typeface="Cambria" pitchFamily="34" charset="0"/>
-                <a:ea typeface="Cambria" pitchFamily="34" charset="-122"/>
-                <a:cs typeface="Cambria" pitchFamily="34" charset="-120"/>
-              </a:rPr>
-              <a:t>간호사가</a:t>
-            </a:r>
-            <a:r>
               <a:rPr lang="en-US" sz="2600" i="1" dirty="0">
                 <a:solidFill>
                   <a:srgbClr val="FFFFFF"/>
@@ -5336,40 +5140,7 @@
                 <a:ea typeface="Cambria" pitchFamily="34" charset="-122"/>
                 <a:cs typeface="Cambria" pitchFamily="34" charset="-120"/>
               </a:rPr>
-              <a:t> </a:t>
-            </a:r>
-            <a:r>
-              <a:rPr lang="en-US" sz="2600" i="1" dirty="0" err="1">
-                <a:solidFill>
-                  <a:srgbClr val="FFFFFF"/>
-                </a:solidFill>
-                <a:latin typeface="Cambria" pitchFamily="34" charset="0"/>
-                <a:ea typeface="Cambria" pitchFamily="34" charset="-122"/>
-                <a:cs typeface="Cambria" pitchFamily="34" charset="-120"/>
-              </a:rPr>
-              <a:t>다급히</a:t>
-            </a:r>
-            <a:r>
-              <a:rPr lang="en-US" sz="2600" i="1" dirty="0">
-                <a:solidFill>
-                  <a:srgbClr val="FFFFFF"/>
-                </a:solidFill>
-                <a:latin typeface="Cambria" pitchFamily="34" charset="0"/>
-                <a:ea typeface="Cambria" pitchFamily="34" charset="-122"/>
-                <a:cs typeface="Cambria" pitchFamily="34" charset="-120"/>
-              </a:rPr>
-              <a:t> </a:t>
-            </a:r>
-            <a:r>
-              <a:rPr lang="ko-KR" altLang="en-US" sz="2600" i="1" dirty="0">
-                <a:solidFill>
-                  <a:srgbClr val="FFFFFF"/>
-                </a:solidFill>
-                <a:latin typeface="Cambria" pitchFamily="34" charset="0"/>
-                <a:ea typeface="Cambria" pitchFamily="34" charset="-122"/>
-                <a:cs typeface="Cambria" pitchFamily="34" charset="-120"/>
-              </a:rPr>
-              <a:t> 진료실 문을 두드린다</a:t>
+              <a:t> 119 구급대의 다급한 무선 보고가 들어온다.</a:t>
             </a:r>
             <a:endParaRPr lang="en-US" sz="2600" dirty="0"/>
           </a:p>
@@ -6208,6 +5979,1336 @@
 
 <file path=ppt/slides/slide3.xml><?xml version="1.0" encoding="utf-8"?>
 <p:sld xmlns:a="http://schemas.openxmlformats.org/drawingml/2006/main" xmlns:r="http://schemas.openxmlformats.org/officeDocument/2006/relationships" xmlns:p="http://schemas.openxmlformats.org/presentationml/2006/main">
+  <p:cSld name="Slide 9">
+    <p:bg>
+      <p:bgPr>
+        <a:solidFill>
+          <a:srgbClr val="3D1509"/>
+        </a:solidFill>
+        <a:effectLst/>
+      </p:bgPr>
+    </p:bg>
+    <p:spTree>
+      <p:nvGrpSpPr>
+        <p:cNvPr id="1" name=""/>
+        <p:cNvGrpSpPr/>
+        <p:nvPr/>
+      </p:nvGrpSpPr>
+      <p:grpSpPr>
+        <a:xfrm>
+          <a:off x="0" y="0"/>
+          <a:ext cx="0" cy="0"/>
+          <a:chOff x="0" y="0"/>
+          <a:chExt cx="0" cy="0"/>
+        </a:xfrm>
+      </p:grpSpPr>
+      <p:sp>
+        <p:nvSpPr>
+          <p:cNvPr id="6" name="Shape 3"/>
+          <p:cNvSpPr/>
+          <p:nvPr/>
+        </p:nvSpPr>
+        <p:spPr>
+          <a:xfrm>
+            <a:off x="640080" y="2697480"/>
+            <a:ext cx="10911535" cy="1828800"/>
+          </a:xfrm>
+          <a:prstGeom prst="roundRect">
+            <a:avLst>
+              <a:gd name="adj" fmla="val 7000"/>
+            </a:avLst>
+          </a:prstGeom>
+          <a:solidFill>
+            <a:srgbClr val="FFFFFF"/>
+          </a:solidFill>
+          <a:ln/>
+          <a:effectLst>
+            <a:outerShdw blurRad="127000" dist="38100" dir="5400000" algn="bl" rotWithShape="0">
+              <a:srgbClr val="1B2E2C">
+                <a:alpha val="12000"/>
+              </a:srgbClr>
+            </a:outerShdw>
+          </a:effectLst>
+        </p:spPr>
+        <p:txBody>
+          <a:bodyPr/>
+          <a:lstStyle/>
+          <a:p>
+            <a:endParaRPr lang="ko-KR" altLang="en-US" dirty="0"/>
+          </a:p>
+        </p:txBody>
+      </p:sp>
+      <p:pic>
+        <p:nvPicPr>
+          <p:cNvPr id="7" name="Image 1" descr="preencoded.png"/>
+          <p:cNvPicPr>
+            <a:picLocks noChangeAspect="1"/>
+          </p:cNvPicPr>
+          <p:nvPr/>
+        </p:nvPicPr>
+        <p:blipFill>
+          <a:blip r:embed="rId5"/>
+          <a:stretch>
+            <a:fillRect/>
+          </a:stretch>
+        </p:blipFill>
+        <p:spPr>
+          <a:xfrm>
+            <a:off x="1005840" y="2953512"/>
+            <a:ext cx="365760" cy="365760"/>
+          </a:xfrm>
+          <a:prstGeom prst="rect">
+            <a:avLst/>
+          </a:prstGeom>
+        </p:spPr>
+      </p:pic>
+      <p:sp>
+        <p:nvSpPr>
+          <p:cNvPr id="8" name="Text 4"/>
+          <p:cNvSpPr/>
+          <p:nvPr/>
+        </p:nvSpPr>
+        <p:spPr>
+          <a:xfrm>
+            <a:off x="1600200" y="2862072"/>
+            <a:ext cx="9585655" cy="1143000"/>
+          </a:xfrm>
+          <a:prstGeom prst="rect">
+            <a:avLst/>
+          </a:prstGeom>
+          <a:noFill/>
+          <a:ln/>
+        </p:spPr>
+        <p:txBody>
+          <a:bodyPr wrap="square" lIns="0" tIns="0" rIns="0" bIns="0" rtlCol="0" anchor="ctr"/>
+          <a:lstStyle/>
+          <a:p>
+            <a:pPr marL="0" indent="0">
+              <a:lnSpc>
+                <a:spcPct val="115000"/>
+              </a:lnSpc>
+              <a:buNone/>
+            </a:pPr>
+            <a:r>
+              <a:rPr lang="en-US" sz="2100" i="1" dirty="0">
+                <a:solidFill>
+                  <a:srgbClr val="13292A"/>
+                </a:solidFill>
+                <a:latin typeface="Cambria" pitchFamily="34" charset="0"/>
+                <a:ea typeface="Cambria" pitchFamily="34" charset="-122"/>
+                <a:cs typeface="Cambria" pitchFamily="34" charset="-120"/>
+              </a:rPr>
+              <a:t>6세 </a:t>
+            </a:r>
+            <a:r>
+              <a:rPr lang="ko-KR" altLang="en-US" sz="2100" i="1" dirty="0">
+                <a:solidFill>
+                  <a:srgbClr val="13292A"/>
+                </a:solidFill>
+                <a:latin typeface="Cambria" pitchFamily="34" charset="0"/>
+                <a:ea typeface="Cambria" pitchFamily="34" charset="-122"/>
+                <a:cs typeface="Cambria" pitchFamily="34" charset="-120"/>
+              </a:rPr>
+              <a:t> 여아 보행자  </a:t>
+            </a:r>
+            <a:r>
+              <a:rPr lang="en-US" altLang="ko-KR" sz="2100" i="1" dirty="0">
+                <a:solidFill>
+                  <a:srgbClr val="13292A"/>
+                </a:solidFill>
+                <a:latin typeface="Cambria" pitchFamily="34" charset="0"/>
+                <a:ea typeface="Cambria" pitchFamily="34" charset="-122"/>
+                <a:cs typeface="Cambria" pitchFamily="34" charset="-120"/>
+              </a:rPr>
+              <a:t>TA</a:t>
+            </a:r>
+            <a:r>
+              <a:rPr lang="ko-KR" altLang="en-US" sz="2100" i="1" dirty="0">
+                <a:solidFill>
+                  <a:srgbClr val="13292A"/>
+                </a:solidFill>
+                <a:latin typeface="Cambria" pitchFamily="34" charset="0"/>
+                <a:ea typeface="Cambria" pitchFamily="34" charset="-122"/>
+                <a:cs typeface="Cambria" pitchFamily="34" charset="-120"/>
+              </a:rPr>
+              <a:t>입니다</a:t>
+            </a:r>
+            <a:r>
+              <a:rPr lang="en-US" sz="2100" i="1" dirty="0">
+                <a:solidFill>
+                  <a:srgbClr val="13292A"/>
+                </a:solidFill>
+                <a:latin typeface="Cambria" pitchFamily="34" charset="0"/>
+                <a:ea typeface="Cambria" pitchFamily="34" charset="-122"/>
+                <a:cs typeface="Cambria" pitchFamily="34" charset="-120"/>
+              </a:rPr>
+              <a:t>.</a:t>
+            </a:r>
+            <a:r>
+              <a:rPr lang="ko-KR" altLang="en-US" sz="2100" i="1" dirty="0">
+                <a:solidFill>
+                  <a:srgbClr val="13292A"/>
+                </a:solidFill>
+                <a:latin typeface="Cambria" pitchFamily="34" charset="0"/>
+                <a:ea typeface="Cambria" pitchFamily="34" charset="-122"/>
+                <a:cs typeface="Cambria" pitchFamily="34" charset="-120"/>
+              </a:rPr>
+              <a:t> 지나가던 행인에 의해 신고되었고 보호자 연락은 돼서 </a:t>
+            </a:r>
+            <a:r>
+              <a:rPr lang="ko-KR" altLang="en-US" sz="2100" i="1" dirty="0" err="1">
+                <a:solidFill>
+                  <a:srgbClr val="13292A"/>
+                </a:solidFill>
+                <a:latin typeface="Cambria" pitchFamily="34" charset="0"/>
+                <a:ea typeface="Cambria" pitchFamily="34" charset="-122"/>
+                <a:cs typeface="Cambria" pitchFamily="34" charset="-120"/>
+              </a:rPr>
+              <a:t>오고계십니다</a:t>
+            </a:r>
+            <a:r>
+              <a:rPr lang="en-US" altLang="ko-KR" sz="2100" i="1" dirty="0">
+                <a:solidFill>
+                  <a:srgbClr val="13292A"/>
+                </a:solidFill>
+                <a:latin typeface="Cambria" pitchFamily="34" charset="0"/>
+                <a:ea typeface="Cambria" pitchFamily="34" charset="-122"/>
+                <a:cs typeface="Cambria" pitchFamily="34" charset="-120"/>
+              </a:rPr>
+              <a:t>.</a:t>
+            </a:r>
+            <a:r>
+              <a:rPr lang="ko-KR" altLang="en-US" sz="2100" i="1" dirty="0">
+                <a:solidFill>
+                  <a:srgbClr val="13292A"/>
+                </a:solidFill>
+                <a:latin typeface="Cambria" pitchFamily="34" charset="0"/>
+                <a:ea typeface="Cambria" pitchFamily="34" charset="-122"/>
+                <a:cs typeface="Cambria" pitchFamily="34" charset="-120"/>
+              </a:rPr>
+              <a:t> </a:t>
+            </a:r>
+            <a:r>
+              <a:rPr lang="ko-KR" altLang="en-US" sz="2100" i="1" dirty="0" err="1">
+                <a:solidFill>
+                  <a:srgbClr val="13292A"/>
+                </a:solidFill>
+                <a:latin typeface="Cambria" pitchFamily="34" charset="0"/>
+                <a:ea typeface="Cambria" pitchFamily="34" charset="-122"/>
+                <a:cs typeface="Cambria" pitchFamily="34" charset="-120"/>
+              </a:rPr>
+              <a:t>멘탈이</a:t>
+            </a:r>
+            <a:r>
+              <a:rPr lang="ko-KR" altLang="en-US" sz="2100" i="1" dirty="0">
+                <a:solidFill>
+                  <a:srgbClr val="13292A"/>
+                </a:solidFill>
+                <a:latin typeface="Cambria" pitchFamily="34" charset="0"/>
+                <a:ea typeface="Cambria" pitchFamily="34" charset="-122"/>
+                <a:cs typeface="Cambria" pitchFamily="34" charset="-120"/>
+              </a:rPr>
+              <a:t> 약간 쳐지고 있는데 수용 가능할까요</a:t>
+            </a:r>
+            <a:r>
+              <a:rPr lang="en-US" altLang="ko-KR" sz="2100" i="1" dirty="0">
+                <a:solidFill>
+                  <a:srgbClr val="13292A"/>
+                </a:solidFill>
+                <a:latin typeface="Cambria" pitchFamily="34" charset="0"/>
+                <a:ea typeface="Cambria" pitchFamily="34" charset="-122"/>
+                <a:cs typeface="Cambria" pitchFamily="34" charset="-120"/>
+              </a:rPr>
+              <a:t>?</a:t>
+            </a:r>
+            <a:endParaRPr lang="en-US" sz="2100" dirty="0"/>
+          </a:p>
+        </p:txBody>
+      </p:sp>
+      <p:sp>
+        <p:nvSpPr>
+          <p:cNvPr id="9" name="Text 5"/>
+          <p:cNvSpPr/>
+          <p:nvPr/>
+        </p:nvSpPr>
+        <p:spPr>
+          <a:xfrm>
+            <a:off x="1600200" y="4069080"/>
+            <a:ext cx="3657600" cy="320040"/>
+          </a:xfrm>
+          <a:prstGeom prst="rect">
+            <a:avLst/>
+          </a:prstGeom>
+          <a:noFill/>
+          <a:ln/>
+        </p:spPr>
+        <p:txBody>
+          <a:bodyPr wrap="square" lIns="0" tIns="0" rIns="0" bIns="0" rtlCol="0" anchor="ctr"/>
+          <a:lstStyle/>
+          <a:p>
+            <a:pPr marL="0" indent="0">
+              <a:buNone/>
+            </a:pPr>
+            <a:r>
+              <a:rPr lang="en-US" sz="1200" b="1" kern="0" spc="100" dirty="0" err="1">
+                <a:solidFill>
+                  <a:srgbClr val="C1440E"/>
+                </a:solidFill>
+                <a:latin typeface="Calibri" pitchFamily="34" charset="0"/>
+                <a:ea typeface="Calibri" pitchFamily="34" charset="-122"/>
+                <a:cs typeface="Calibri" pitchFamily="34" charset="-120"/>
+              </a:rPr>
+              <a:t>송파</a:t>
+            </a:r>
+            <a:r>
+              <a:rPr lang="ko-KR" altLang="en-US" sz="1200" b="1" kern="0" spc="100" dirty="0">
+                <a:solidFill>
+                  <a:srgbClr val="C1440E"/>
+                </a:solidFill>
+                <a:latin typeface="Calibri" pitchFamily="34" charset="0"/>
+                <a:ea typeface="Calibri" pitchFamily="34" charset="-122"/>
+                <a:cs typeface="Calibri" pitchFamily="34" charset="-120"/>
+              </a:rPr>
+              <a:t> </a:t>
+            </a:r>
+            <a:r>
+              <a:rPr lang="en-US" sz="1200" b="1" kern="0" spc="100" dirty="0">
+                <a:solidFill>
+                  <a:srgbClr val="C1440E"/>
+                </a:solidFill>
+                <a:latin typeface="Calibri" pitchFamily="34" charset="0"/>
+                <a:ea typeface="Calibri" pitchFamily="34" charset="-122"/>
+                <a:cs typeface="Calibri" pitchFamily="34" charset="-120"/>
+              </a:rPr>
+              <a:t>119 </a:t>
+            </a:r>
+            <a:r>
+              <a:rPr lang="en-US" sz="1200" b="1" kern="0" spc="100" dirty="0" err="1">
+                <a:solidFill>
+                  <a:srgbClr val="C1440E"/>
+                </a:solidFill>
+                <a:latin typeface="Calibri" pitchFamily="34" charset="0"/>
+                <a:ea typeface="Calibri" pitchFamily="34" charset="-122"/>
+                <a:cs typeface="Calibri" pitchFamily="34" charset="-120"/>
+              </a:rPr>
+              <a:t>구급대</a:t>
+            </a:r>
+            <a:r>
+              <a:rPr lang="en-US" sz="1200" b="1" kern="0" spc="100" dirty="0">
+                <a:solidFill>
+                  <a:srgbClr val="C1440E"/>
+                </a:solidFill>
+                <a:latin typeface="Calibri" pitchFamily="34" charset="0"/>
+                <a:ea typeface="Calibri" pitchFamily="34" charset="-122"/>
+                <a:cs typeface="Calibri" pitchFamily="34" charset="-120"/>
+              </a:rPr>
+              <a:t> </a:t>
+            </a:r>
+            <a:endParaRPr lang="en-US" sz="1200" dirty="0"/>
+          </a:p>
+        </p:txBody>
+      </p:sp>
+      <p:pic>
+        <p:nvPicPr>
+          <p:cNvPr id="4" name="오디오 3">
+            <a:extLst>
+              <a:ext uri="{FF2B5EF4-FFF2-40B4-BE49-F238E27FC236}">
+                <a16:creationId xmlns:a16="http://schemas.microsoft.com/office/drawing/2014/main" id="{112E9FD6-280C-6578-0B2C-1A8A56958D87}"/>
+              </a:ext>
+            </a:extLst>
+          </p:cNvPr>
+          <p:cNvPicPr>
+            <a:picLocks noChangeAspect="1"/>
+          </p:cNvPicPr>
+          <p:nvPr>
+            <a:audioFile r:link="rId2"/>
+            <p:extLst>
+              <p:ext uri="{DAA4B4D4-6D71-4841-9C94-3DE7FCFB9230}">
+                <p14:media xmlns:p14="http://schemas.microsoft.com/office/powerpoint/2010/main" r:embed="rId1"/>
+              </p:ext>
+            </p:extLst>
+          </p:nvPr>
+        </p:nvPicPr>
+        <p:blipFill>
+          <a:blip r:embed="rId6"/>
+          <a:stretch>
+            <a:fillRect/>
+          </a:stretch>
+        </p:blipFill>
+        <p:spPr>
+          <a:xfrm>
+            <a:off x="11226800" y="5892800"/>
+            <a:ext cx="812800" cy="812800"/>
+          </a:xfrm>
+          <a:prstGeom prst="rect">
+            <a:avLst/>
+          </a:prstGeom>
+        </p:spPr>
+      </p:pic>
+    </p:spTree>
+  </p:cSld>
+  <p:clrMapOvr>
+    <a:masterClrMapping/>
+  </p:clrMapOvr>
+  <mc:AlternateContent xmlns:mc="http://schemas.openxmlformats.org/markup-compatibility/2006">
+    <mc:Choice xmlns:p14="http://schemas.microsoft.com/office/powerpoint/2010/main" Requires="p14">
+      <p:transition spd="slow" p14:dur="2000" advTm="11212"/>
+    </mc:Choice>
+    <mc:Fallback>
+      <p:transition spd="slow" advTm="11212"/>
+    </mc:Fallback>
+  </mc:AlternateContent>
+  <p:timing>
+    <p:tnLst>
+      <p:par>
+        <p:cTn id="1" dur="indefinite" restart="never" nodeType="tmRoot">
+          <p:childTnLst>
+            <p:seq concurrent="1" nextAc="seek">
+              <p:cTn id="2" dur="indefinite" nodeType="mainSeq">
+                <p:childTnLst>
+                  <p:par>
+                    <p:cTn id="3" fill="hold">
+                      <p:stCondLst>
+                        <p:cond delay="indefinite"/>
+                        <p:cond evt="onBegin" delay="0">
+                          <p:tn val="2"/>
+                        </p:cond>
+                      </p:stCondLst>
+                      <p:childTnLst>
+                        <p:par>
+                          <p:cTn id="4" fill="hold">
+                            <p:stCondLst>
+                              <p:cond delay="0"/>
+                            </p:stCondLst>
+                            <p:childTnLst>
+                              <p:par>
+                                <p:cTn id="5" presetID="1" presetClass="mediacall" presetSubtype="0" fill="hold" nodeType="afterEffect">
+                                  <p:stCondLst>
+                                    <p:cond delay="0"/>
+                                  </p:stCondLst>
+                                  <p:childTnLst>
+                                    <p:cmd type="call" cmd="playFrom(0.0)">
+                                      <p:cBhvr>
+                                        <p:cTn id="6" dur="1" fill="hold"/>
+                                        <p:tgtEl>
+                                          <p:spTgt spid="4"/>
+                                        </p:tgtEl>
+                                      </p:cBhvr>
+                                    </p:cmd>
+                                  </p:childTnLst>
+                                </p:cTn>
+                              </p:par>
+                            </p:childTnLst>
+                          </p:cTn>
+                        </p:par>
+                      </p:childTnLst>
+                    </p:cTn>
+                  </p:par>
+                </p:childTnLst>
+              </p:cTn>
+              <p:prevCondLst>
+                <p:cond evt="onPrev" delay="0">
+                  <p:tgtEl>
+                    <p:sldTgt/>
+                  </p:tgtEl>
+                </p:cond>
+              </p:prevCondLst>
+              <p:nextCondLst>
+                <p:cond evt="onNext" delay="0">
+                  <p:tgtEl>
+                    <p:sldTgt/>
+                  </p:tgtEl>
+                </p:cond>
+              </p:nextCondLst>
+            </p:seq>
+            <p:audio isNarration="1">
+              <p:cMediaNode vol="80000" showWhenStopped="0">
+                <p:cTn id="7" fill="hold" display="0">
+                  <p:stCondLst>
+                    <p:cond delay="indefinite"/>
+                  </p:stCondLst>
+                  <p:endCondLst>
+                    <p:cond evt="onStopAudio" delay="0">
+                      <p:tgtEl>
+                        <p:sldTgt/>
+                      </p:tgtEl>
+                    </p:cond>
+                  </p:endCondLst>
+                </p:cTn>
+                <p:tgtEl>
+                  <p:spTgt spid="4"/>
+                </p:tgtEl>
+              </p:cMediaNode>
+            </p:audio>
+          </p:childTnLst>
+        </p:cTn>
+      </p:par>
+    </p:tnLst>
+  </p:timing>
+</p:sld>
+</file>
+
+<file path=ppt/slides/slide4.xml><?xml version="1.0" encoding="utf-8"?>
+<p:sld xmlns:a="http://schemas.openxmlformats.org/drawingml/2006/main" xmlns:r="http://schemas.openxmlformats.org/officeDocument/2006/relationships" xmlns:p="http://schemas.openxmlformats.org/presentationml/2006/main">
+  <p:cSld name="Slide 11">
+    <p:bg>
+      <p:bgPr>
+        <a:solidFill>
+          <a:srgbClr val="3D1509"/>
+        </a:solidFill>
+        <a:effectLst/>
+      </p:bgPr>
+    </p:bg>
+    <p:spTree>
+      <p:nvGrpSpPr>
+        <p:cNvPr id="1" name=""/>
+        <p:cNvGrpSpPr/>
+        <p:nvPr/>
+      </p:nvGrpSpPr>
+      <p:grpSpPr>
+        <a:xfrm>
+          <a:off x="0" y="0"/>
+          <a:ext cx="0" cy="0"/>
+          <a:chOff x="0" y="0"/>
+          <a:chExt cx="0" cy="0"/>
+        </a:xfrm>
+      </p:grpSpPr>
+      <p:sp>
+        <p:nvSpPr>
+          <p:cNvPr id="3" name="Text 1"/>
+          <p:cNvSpPr/>
+          <p:nvPr/>
+        </p:nvSpPr>
+        <p:spPr>
+          <a:xfrm>
+            <a:off x="1280160" y="1296785"/>
+            <a:ext cx="9631375" cy="4488873"/>
+          </a:xfrm>
+          <a:prstGeom prst="rect">
+            <a:avLst/>
+          </a:prstGeom>
+          <a:noFill/>
+          <a:ln/>
+        </p:spPr>
+        <p:txBody>
+          <a:bodyPr wrap="square" lIns="0" tIns="0" rIns="0" bIns="0" rtlCol="0" anchor="ctr"/>
+          <a:lstStyle/>
+          <a:p>
+            <a:pPr marL="0" indent="0" algn="ctr">
+              <a:lnSpc>
+                <a:spcPct val="135000"/>
+              </a:lnSpc>
+              <a:buNone/>
+            </a:pPr>
+            <a:r>
+              <a:rPr lang="en-US" sz="2600" i="1" dirty="0" err="1">
+                <a:solidFill>
+                  <a:srgbClr val="FFFFFF"/>
+                </a:solidFill>
+                <a:latin typeface="Cambria" pitchFamily="34" charset="0"/>
+                <a:ea typeface="Cambria" pitchFamily="34" charset="-122"/>
+                <a:cs typeface="Cambria" pitchFamily="34" charset="-120"/>
+              </a:rPr>
+              <a:t>최대한</a:t>
+            </a:r>
+            <a:r>
+              <a:rPr lang="ko-KR" altLang="en-US" sz="2600" i="1" dirty="0">
+                <a:solidFill>
+                  <a:srgbClr val="FFFFFF"/>
+                </a:solidFill>
+                <a:latin typeface="Cambria" pitchFamily="34" charset="0"/>
+                <a:ea typeface="Cambria" pitchFamily="34" charset="-122"/>
+                <a:cs typeface="Cambria" pitchFamily="34" charset="-120"/>
+              </a:rPr>
+              <a:t> 빨리 이송해달라고 답변하고 전화를 </a:t>
+            </a:r>
+            <a:r>
+              <a:rPr lang="ko-KR" altLang="en-US" sz="2600" i="1" dirty="0" err="1">
+                <a:solidFill>
+                  <a:srgbClr val="FFFFFF"/>
+                </a:solidFill>
+                <a:latin typeface="Cambria" pitchFamily="34" charset="0"/>
+                <a:ea typeface="Cambria" pitchFamily="34" charset="-122"/>
+                <a:cs typeface="Cambria" pitchFamily="34" charset="-120"/>
+              </a:rPr>
+              <a:t>끊은지</a:t>
+            </a:r>
+            <a:r>
+              <a:rPr lang="ko-KR" altLang="en-US" sz="2600" i="1" dirty="0">
+                <a:solidFill>
+                  <a:srgbClr val="FFFFFF"/>
+                </a:solidFill>
+                <a:latin typeface="Cambria" pitchFamily="34" charset="0"/>
+                <a:ea typeface="Cambria" pitchFamily="34" charset="-122"/>
+                <a:cs typeface="Cambria" pitchFamily="34" charset="-120"/>
+              </a:rPr>
+              <a:t> 얼마 되지 않아</a:t>
+            </a:r>
+            <a:r>
+              <a:rPr lang="en-US" sz="2600" i="1" dirty="0" err="1">
+                <a:solidFill>
+                  <a:srgbClr val="FFFFFF"/>
+                </a:solidFill>
+                <a:latin typeface="Cambria" pitchFamily="34" charset="0"/>
+                <a:ea typeface="Cambria" pitchFamily="34" charset="-122"/>
+                <a:cs typeface="Cambria" pitchFamily="34" charset="-120"/>
+              </a:rPr>
+              <a:t>사이렌</a:t>
+            </a:r>
+            <a:r>
+              <a:rPr lang="en-US" sz="2600" i="1" dirty="0">
+                <a:solidFill>
+                  <a:srgbClr val="FFFFFF"/>
+                </a:solidFill>
+                <a:latin typeface="Cambria" pitchFamily="34" charset="0"/>
+                <a:ea typeface="Cambria" pitchFamily="34" charset="-122"/>
+                <a:cs typeface="Cambria" pitchFamily="34" charset="-120"/>
+              </a:rPr>
+              <a:t> </a:t>
+            </a:r>
+            <a:r>
+              <a:rPr lang="en-US" sz="2600" i="1" dirty="0" err="1">
+                <a:solidFill>
+                  <a:srgbClr val="FFFFFF"/>
+                </a:solidFill>
+                <a:latin typeface="Cambria" pitchFamily="34" charset="0"/>
+                <a:ea typeface="Cambria" pitchFamily="34" charset="-122"/>
+                <a:cs typeface="Cambria" pitchFamily="34" charset="-120"/>
+              </a:rPr>
+              <a:t>소리가</a:t>
+            </a:r>
+            <a:r>
+              <a:rPr lang="en-US" sz="2600" i="1" dirty="0">
+                <a:solidFill>
+                  <a:srgbClr val="FFFFFF"/>
+                </a:solidFill>
+                <a:latin typeface="Cambria" pitchFamily="34" charset="0"/>
+                <a:ea typeface="Cambria" pitchFamily="34" charset="-122"/>
+                <a:cs typeface="Cambria" pitchFamily="34" charset="-120"/>
+              </a:rPr>
+              <a:t> </a:t>
+            </a:r>
+            <a:r>
+              <a:rPr lang="en-US" sz="2600" i="1" dirty="0" err="1">
+                <a:solidFill>
+                  <a:srgbClr val="FFFFFF"/>
+                </a:solidFill>
+                <a:latin typeface="Cambria" pitchFamily="34" charset="0"/>
+                <a:ea typeface="Cambria" pitchFamily="34" charset="-122"/>
+                <a:cs typeface="Cambria" pitchFamily="34" charset="-120"/>
+              </a:rPr>
+              <a:t>들리기</a:t>
+            </a:r>
+            <a:r>
+              <a:rPr lang="ko-KR" altLang="en-US" sz="2600" i="1" dirty="0">
+                <a:solidFill>
+                  <a:srgbClr val="FFFFFF"/>
+                </a:solidFill>
+                <a:latin typeface="Cambria" pitchFamily="34" charset="0"/>
+                <a:ea typeface="Cambria" pitchFamily="34" charset="-122"/>
+                <a:cs typeface="Cambria" pitchFamily="34" charset="-120"/>
+              </a:rPr>
+              <a:t> 시작한다</a:t>
+            </a:r>
+            <a:r>
+              <a:rPr lang="en-US" sz="2600" i="1" dirty="0">
+                <a:solidFill>
+                  <a:srgbClr val="FFFFFF"/>
+                </a:solidFill>
+                <a:latin typeface="Cambria" pitchFamily="34" charset="0"/>
+                <a:ea typeface="Cambria" pitchFamily="34" charset="-122"/>
+                <a:cs typeface="Cambria" pitchFamily="34" charset="-120"/>
+              </a:rPr>
+              <a:t>. </a:t>
+            </a:r>
+          </a:p>
+          <a:p>
+            <a:pPr marL="0" indent="0" algn="ctr">
+              <a:lnSpc>
+                <a:spcPct val="135000"/>
+              </a:lnSpc>
+              <a:buNone/>
+            </a:pPr>
+            <a:r>
+              <a:rPr lang="en-US" sz="2600" i="1" dirty="0" err="1">
+                <a:solidFill>
+                  <a:srgbClr val="FFFFFF"/>
+                </a:solidFill>
+                <a:latin typeface="Cambria" pitchFamily="34" charset="0"/>
+                <a:ea typeface="Cambria" pitchFamily="34" charset="-122"/>
+                <a:cs typeface="Cambria" pitchFamily="34" charset="-120"/>
+              </a:rPr>
+              <a:t>처치실에</a:t>
+            </a:r>
+            <a:r>
+              <a:rPr lang="ko-KR" altLang="en-US" sz="2600" i="1" dirty="0">
+                <a:solidFill>
+                  <a:srgbClr val="FFFFFF"/>
+                </a:solidFill>
+                <a:latin typeface="Cambria" pitchFamily="34" charset="0"/>
+                <a:ea typeface="Cambria" pitchFamily="34" charset="-122"/>
+                <a:cs typeface="Cambria" pitchFamily="34" charset="-120"/>
+              </a:rPr>
+              <a:t> 환자 받는 준비로 어수선하다</a:t>
+            </a:r>
+            <a:r>
+              <a:rPr lang="en-US" altLang="ko-KR" sz="2600" i="1" dirty="0">
+                <a:solidFill>
+                  <a:srgbClr val="FFFFFF"/>
+                </a:solidFill>
+                <a:latin typeface="Cambria" pitchFamily="34" charset="0"/>
+                <a:ea typeface="Cambria" pitchFamily="34" charset="-122"/>
+                <a:cs typeface="Cambria" pitchFamily="34" charset="-120"/>
+              </a:rPr>
+              <a:t>.</a:t>
+            </a:r>
+            <a:r>
+              <a:rPr lang="ko-KR" altLang="en-US" sz="2600" i="1" dirty="0">
+                <a:solidFill>
+                  <a:srgbClr val="FFFFFF"/>
+                </a:solidFill>
+                <a:latin typeface="Cambria" pitchFamily="34" charset="0"/>
+                <a:ea typeface="Cambria" pitchFamily="34" charset="-122"/>
+                <a:cs typeface="Cambria" pitchFamily="34" charset="-120"/>
+              </a:rPr>
+              <a:t> </a:t>
+            </a:r>
+            <a:endParaRPr lang="en-US" altLang="ko-KR" sz="2600" i="1" dirty="0">
+              <a:solidFill>
+                <a:srgbClr val="FFFFFF"/>
+              </a:solidFill>
+              <a:latin typeface="Cambria" pitchFamily="34" charset="0"/>
+              <a:ea typeface="Cambria" pitchFamily="34" charset="-122"/>
+              <a:cs typeface="Cambria" pitchFamily="34" charset="-120"/>
+            </a:endParaRPr>
+          </a:p>
+          <a:p>
+            <a:pPr marL="0" indent="0" algn="ctr">
+              <a:lnSpc>
+                <a:spcPct val="135000"/>
+              </a:lnSpc>
+              <a:buNone/>
+            </a:pPr>
+            <a:endParaRPr lang="en-US" sz="2600" dirty="0"/>
+          </a:p>
+          <a:p>
+            <a:pPr marL="0" indent="0" algn="ctr">
+              <a:lnSpc>
+                <a:spcPct val="135000"/>
+              </a:lnSpc>
+              <a:buNone/>
+            </a:pPr>
+            <a:r>
+              <a:rPr lang="en-US" sz="2600" i="1" dirty="0">
+                <a:solidFill>
+                  <a:srgbClr val="FFFFFF"/>
+                </a:solidFill>
+                <a:latin typeface="Cambria" pitchFamily="34" charset="0"/>
+                <a:ea typeface="Cambria" pitchFamily="34" charset="-122"/>
+                <a:cs typeface="Cambria" pitchFamily="34" charset="-120"/>
+              </a:rPr>
+              <a:t>심상치 않은 손상 기전을 직감한 당신은 곧바로 치프 </a:t>
+            </a:r>
+            <a:r>
+              <a:rPr lang="en-US" sz="2600" i="1" dirty="0" err="1">
+                <a:solidFill>
+                  <a:srgbClr val="FFFFFF"/>
+                </a:solidFill>
+                <a:latin typeface="Cambria" pitchFamily="34" charset="0"/>
+                <a:ea typeface="Cambria" pitchFamily="34" charset="-122"/>
+                <a:cs typeface="Cambria" pitchFamily="34" charset="-120"/>
+              </a:rPr>
+              <a:t>당직과</a:t>
+            </a:r>
+            <a:r>
+              <a:rPr lang="en-US" sz="2600" i="1" dirty="0">
+                <a:solidFill>
+                  <a:srgbClr val="FFFFFF"/>
+                </a:solidFill>
+                <a:latin typeface="Cambria" pitchFamily="34" charset="0"/>
+                <a:ea typeface="Cambria" pitchFamily="34" charset="-122"/>
+                <a:cs typeface="Cambria" pitchFamily="34" charset="-120"/>
+              </a:rPr>
+              <a:t> </a:t>
+            </a:r>
+            <a:r>
+              <a:rPr lang="en-US" sz="2600" i="1" dirty="0" err="1">
+                <a:solidFill>
+                  <a:srgbClr val="FFFFFF"/>
+                </a:solidFill>
+                <a:latin typeface="Cambria" pitchFamily="34" charset="0"/>
+                <a:ea typeface="Cambria" pitchFamily="34" charset="-122"/>
+                <a:cs typeface="Cambria" pitchFamily="34" charset="-120"/>
+              </a:rPr>
+              <a:t>중환자실당직에게</a:t>
+            </a:r>
+            <a:r>
+              <a:rPr lang="en-US" sz="2600" i="1" dirty="0">
+                <a:solidFill>
+                  <a:srgbClr val="FFFFFF"/>
+                </a:solidFill>
+                <a:latin typeface="Cambria" pitchFamily="34" charset="0"/>
+                <a:ea typeface="Cambria" pitchFamily="34" charset="-122"/>
+                <a:cs typeface="Cambria" pitchFamily="34" charset="-120"/>
+              </a:rPr>
+              <a:t> </a:t>
+            </a:r>
+            <a:r>
+              <a:rPr lang="ko-KR" altLang="en-US" sz="2600" i="1" dirty="0">
+                <a:solidFill>
+                  <a:srgbClr val="FFFFFF"/>
+                </a:solidFill>
+                <a:latin typeface="Cambria" pitchFamily="34" charset="0"/>
+                <a:ea typeface="Cambria" pitchFamily="34" charset="-122"/>
+                <a:cs typeface="Cambria" pitchFamily="34" charset="-120"/>
+              </a:rPr>
+              <a:t> 상황을 알린다</a:t>
+            </a:r>
+            <a:r>
+              <a:rPr lang="en-US" sz="2600" i="1" dirty="0">
+                <a:solidFill>
+                  <a:srgbClr val="FFFFFF"/>
+                </a:solidFill>
+                <a:latin typeface="Cambria" pitchFamily="34" charset="0"/>
+                <a:ea typeface="Cambria" pitchFamily="34" charset="-122"/>
+                <a:cs typeface="Cambria" pitchFamily="34" charset="-120"/>
+              </a:rPr>
+              <a:t>. 팀이 모두 모인 순간, 환자가 도착한다.</a:t>
+            </a:r>
+            <a:endParaRPr lang="en-US" sz="2600" dirty="0"/>
+          </a:p>
+        </p:txBody>
+      </p:sp>
+    </p:spTree>
+  </p:cSld>
+  <p:clrMapOvr>
+    <a:masterClrMapping/>
+  </p:clrMapOvr>
+</p:sld>
+</file>
+
+<file path=ppt/slides/slide5.xml><?xml version="1.0" encoding="utf-8"?>
+<p:sld xmlns:a="http://schemas.openxmlformats.org/drawingml/2006/main" xmlns:r="http://schemas.openxmlformats.org/officeDocument/2006/relationships" xmlns:p="http://schemas.openxmlformats.org/presentationml/2006/main">
+  <p:cSld name="Slide 12">
+    <p:bg>
+      <p:bgPr>
+        <a:solidFill>
+          <a:srgbClr val="C1440E"/>
+        </a:solidFill>
+        <a:effectLst/>
+      </p:bgPr>
+    </p:bg>
+    <p:spTree>
+      <p:nvGrpSpPr>
+        <p:cNvPr id="1" name=""/>
+        <p:cNvGrpSpPr/>
+        <p:nvPr/>
+      </p:nvGrpSpPr>
+      <p:grpSpPr>
+        <a:xfrm>
+          <a:off x="0" y="0"/>
+          <a:ext cx="0" cy="0"/>
+          <a:chOff x="0" y="0"/>
+          <a:chExt cx="0" cy="0"/>
+        </a:xfrm>
+      </p:grpSpPr>
+      <p:pic>
+        <p:nvPicPr>
+          <p:cNvPr id="3" name="Image 0" descr="preencoded.png"/>
+          <p:cNvPicPr>
+            <a:picLocks noChangeAspect="1"/>
+          </p:cNvPicPr>
+          <p:nvPr/>
+        </p:nvPicPr>
+        <p:blipFill>
+          <a:blip r:embed="rId3"/>
+          <a:stretch>
+            <a:fillRect/>
+          </a:stretch>
+        </p:blipFill>
+        <p:spPr>
+          <a:xfrm>
+            <a:off x="5730088" y="1920240"/>
+            <a:ext cx="731520" cy="731520"/>
+          </a:xfrm>
+          <a:prstGeom prst="rect">
+            <a:avLst/>
+          </a:prstGeom>
+        </p:spPr>
+      </p:pic>
+      <p:sp>
+        <p:nvSpPr>
+          <p:cNvPr id="4" name="Text 1"/>
+          <p:cNvSpPr/>
+          <p:nvPr/>
+        </p:nvSpPr>
+        <p:spPr>
+          <a:xfrm>
+            <a:off x="1188720" y="2880360"/>
+            <a:ext cx="9814255" cy="1371600"/>
+          </a:xfrm>
+          <a:prstGeom prst="rect">
+            <a:avLst/>
+          </a:prstGeom>
+          <a:noFill/>
+          <a:ln/>
+        </p:spPr>
+        <p:txBody>
+          <a:bodyPr wrap="square" lIns="0" tIns="0" rIns="0" bIns="0" rtlCol="0" anchor="ctr"/>
+          <a:lstStyle/>
+          <a:p>
+            <a:pPr marL="0" indent="0" algn="ctr">
+              <a:lnSpc>
+                <a:spcPct val="120000"/>
+              </a:lnSpc>
+              <a:buNone/>
+            </a:pPr>
+            <a:r>
+              <a:rPr lang="en-US" sz="3000" b="1" dirty="0">
+                <a:solidFill>
+                  <a:srgbClr val="FFFFFF"/>
+                </a:solidFill>
+                <a:latin typeface="Cambria" pitchFamily="34" charset="0"/>
+                <a:ea typeface="Cambria" pitchFamily="34" charset="-122"/>
+                <a:cs typeface="Cambria" pitchFamily="34" charset="-120"/>
+              </a:rPr>
+              <a:t> 다같이</a:t>
+            </a:r>
+            <a:endParaRPr lang="en-US" sz="3000" dirty="0"/>
+          </a:p>
+          <a:p>
+            <a:pPr marL="0" indent="0" algn="ctr">
+              <a:lnSpc>
+                <a:spcPct val="120000"/>
+              </a:lnSpc>
+              <a:buNone/>
+            </a:pPr>
+            <a:r>
+              <a:rPr lang="en-US" sz="3000" b="1" dirty="0">
+                <a:solidFill>
+                  <a:srgbClr val="FFFFFF"/>
+                </a:solidFill>
+                <a:latin typeface="Cambria" pitchFamily="34" charset="0"/>
+                <a:ea typeface="Cambria" pitchFamily="34" charset="-122"/>
+                <a:cs typeface="Cambria" pitchFamily="34" charset="-120"/>
+              </a:rPr>
+              <a:t>초기 평가와 처치 방침을 세우시오.</a:t>
+            </a:r>
+            <a:endParaRPr lang="en-US" sz="3000" dirty="0"/>
+          </a:p>
+        </p:txBody>
+      </p:sp>
+    </p:spTree>
+  </p:cSld>
+  <p:clrMapOvr>
+    <a:masterClrMapping/>
+  </p:clrMapOvr>
+</p:sld>
+</file>
+
+<file path=ppt/slides/slide6.xml><?xml version="1.0" encoding="utf-8"?>
+<p:sld xmlns:a="http://schemas.openxmlformats.org/drawingml/2006/main" xmlns:r="http://schemas.openxmlformats.org/officeDocument/2006/relationships" xmlns:p="http://schemas.openxmlformats.org/presentationml/2006/main">
+  <p:cSld name="Slide 19">
+    <p:bg>
+      <p:bgPr>
+        <a:solidFill>
+          <a:srgbClr val="3A0A22"/>
+        </a:solidFill>
+        <a:effectLst/>
+      </p:bgPr>
+    </p:bg>
+    <p:spTree>
+      <p:nvGrpSpPr>
+        <p:cNvPr id="1" name=""/>
+        <p:cNvGrpSpPr/>
+        <p:nvPr/>
+      </p:nvGrpSpPr>
+      <p:grpSpPr>
+        <a:xfrm>
+          <a:off x="0" y="0"/>
+          <a:ext cx="0" cy="0"/>
+          <a:chOff x="0" y="0"/>
+          <a:chExt cx="0" cy="0"/>
+        </a:xfrm>
+      </p:grpSpPr>
+      <p:pic>
+        <p:nvPicPr>
+          <p:cNvPr id="3" name="Image 0" descr="preencoded.png"/>
+          <p:cNvPicPr>
+            <a:picLocks noChangeAspect="1"/>
+          </p:cNvPicPr>
+          <p:nvPr/>
+        </p:nvPicPr>
+        <p:blipFill>
+          <a:blip r:embed="rId3"/>
+          <a:stretch>
+            <a:fillRect/>
+          </a:stretch>
+        </p:blipFill>
+        <p:spPr>
+          <a:xfrm>
+            <a:off x="5684368" y="1691640"/>
+            <a:ext cx="822960" cy="822960"/>
+          </a:xfrm>
+          <a:prstGeom prst="rect">
+            <a:avLst/>
+          </a:prstGeom>
+        </p:spPr>
+      </p:pic>
+      <p:sp>
+        <p:nvSpPr>
+          <p:cNvPr id="4" name="Text 1"/>
+          <p:cNvSpPr/>
+          <p:nvPr/>
+        </p:nvSpPr>
+        <p:spPr>
+          <a:xfrm>
+            <a:off x="914400" y="2743200"/>
+            <a:ext cx="10362895" cy="1188720"/>
+          </a:xfrm>
+          <a:prstGeom prst="rect">
+            <a:avLst/>
+          </a:prstGeom>
+          <a:noFill/>
+          <a:ln/>
+        </p:spPr>
+        <p:txBody>
+          <a:bodyPr wrap="square" lIns="0" tIns="0" rIns="0" bIns="0" rtlCol="0" anchor="ctr"/>
+          <a:lstStyle/>
+          <a:p>
+            <a:pPr marL="0" indent="0" algn="ctr">
+              <a:buNone/>
+            </a:pPr>
+            <a:r>
+              <a:rPr lang="en-US" sz="5800" b="1" dirty="0" err="1">
+                <a:solidFill>
+                  <a:srgbClr val="FFFFFF"/>
+                </a:solidFill>
+                <a:latin typeface="Cambria" pitchFamily="34" charset="0"/>
+                <a:ea typeface="Cambria" pitchFamily="34" charset="-122"/>
+                <a:cs typeface="Cambria" pitchFamily="34" charset="-120"/>
+              </a:rPr>
+              <a:t>새벽</a:t>
+            </a:r>
+            <a:r>
+              <a:rPr lang="en-US" sz="5800" b="1" dirty="0">
+                <a:solidFill>
+                  <a:srgbClr val="FFFFFF"/>
+                </a:solidFill>
+                <a:latin typeface="Cambria" pitchFamily="34" charset="0"/>
+                <a:ea typeface="Cambria" pitchFamily="34" charset="-122"/>
+                <a:cs typeface="Cambria" pitchFamily="34" charset="-120"/>
+              </a:rPr>
+              <a:t> </a:t>
+            </a:r>
+            <a:r>
+              <a:rPr lang="en-US" altLang="ko-KR" sz="5800" b="1" dirty="0">
+                <a:solidFill>
+                  <a:srgbClr val="FFFFFF"/>
+                </a:solidFill>
+                <a:latin typeface="Cambria" pitchFamily="34" charset="0"/>
+                <a:ea typeface="Cambria" pitchFamily="34" charset="-122"/>
+                <a:cs typeface="Cambria" pitchFamily="34" charset="-120"/>
+              </a:rPr>
+              <a:t>2</a:t>
+            </a:r>
+            <a:r>
+              <a:rPr lang="en-US" sz="5800" b="1" dirty="0">
+                <a:solidFill>
+                  <a:srgbClr val="FFFFFF"/>
+                </a:solidFill>
+                <a:latin typeface="Cambria" pitchFamily="34" charset="0"/>
+                <a:ea typeface="Cambria" pitchFamily="34" charset="-122"/>
+                <a:cs typeface="Cambria" pitchFamily="34" charset="-120"/>
+              </a:rPr>
+              <a:t>시</a:t>
+            </a:r>
+            <a:endParaRPr lang="en-US" sz="5800" dirty="0"/>
+          </a:p>
+        </p:txBody>
+      </p:sp>
+      <p:sp>
+        <p:nvSpPr>
+          <p:cNvPr id="5" name="Text 2"/>
+          <p:cNvSpPr/>
+          <p:nvPr/>
+        </p:nvSpPr>
+        <p:spPr>
+          <a:xfrm>
+            <a:off x="914400" y="3886200"/>
+            <a:ext cx="10362895" cy="365760"/>
+          </a:xfrm>
+          <a:prstGeom prst="rect">
+            <a:avLst/>
+          </a:prstGeom>
+          <a:noFill/>
+          <a:ln/>
+        </p:spPr>
+        <p:txBody>
+          <a:bodyPr wrap="square" lIns="0" tIns="0" rIns="0" bIns="0" rtlCol="0" anchor="ctr"/>
+          <a:lstStyle/>
+          <a:p>
+            <a:pPr marL="0" indent="0" algn="ctr">
+              <a:buNone/>
+            </a:pPr>
+            <a:r>
+              <a:rPr lang="en-US" sz="1400" b="1" kern="0" spc="300" dirty="0" err="1">
+                <a:solidFill>
+                  <a:srgbClr val="E9B8CB"/>
+                </a:solidFill>
+                <a:latin typeface="Calibri" pitchFamily="34" charset="0"/>
+                <a:ea typeface="Calibri" pitchFamily="34" charset="-122"/>
+                <a:cs typeface="Calibri" pitchFamily="34" charset="-120"/>
+              </a:rPr>
+              <a:t>소아응급의료센터</a:t>
+            </a:r>
+            <a:endParaRPr lang="en-US" sz="1400" dirty="0"/>
+          </a:p>
+        </p:txBody>
+      </p:sp>
+    </p:spTree>
+  </p:cSld>
+  <p:clrMapOvr>
+    <a:masterClrMapping/>
+  </p:clrMapOvr>
+</p:sld>
+</file>
+
+<file path=ppt/slides/slide7.xml><?xml version="1.0" encoding="utf-8"?>
+<p:sld xmlns:a="http://schemas.openxmlformats.org/drawingml/2006/main" xmlns:r="http://schemas.openxmlformats.org/officeDocument/2006/relationships" xmlns:p="http://schemas.openxmlformats.org/presentationml/2006/main">
+  <p:cSld name="Slide 20">
+    <p:bg>
+      <p:bgPr>
+        <a:solidFill>
+          <a:srgbClr val="3A0A22"/>
+        </a:solidFill>
+        <a:effectLst/>
+      </p:bgPr>
+    </p:bg>
+    <p:spTree>
+      <p:nvGrpSpPr>
+        <p:cNvPr id="1" name=""/>
+        <p:cNvGrpSpPr/>
+        <p:nvPr/>
+      </p:nvGrpSpPr>
+      <p:grpSpPr>
+        <a:xfrm>
+          <a:off x="0" y="0"/>
+          <a:ext cx="0" cy="0"/>
+          <a:chOff x="0" y="0"/>
+          <a:chExt cx="0" cy="0"/>
+        </a:xfrm>
+      </p:grpSpPr>
+      <p:sp>
+        <p:nvSpPr>
+          <p:cNvPr id="3" name="Text 1"/>
+          <p:cNvSpPr/>
+          <p:nvPr/>
+        </p:nvSpPr>
+        <p:spPr>
+          <a:xfrm>
+            <a:off x="1280160" y="2468880"/>
+            <a:ext cx="9631375" cy="1920240"/>
+          </a:xfrm>
+          <a:prstGeom prst="rect">
+            <a:avLst/>
+          </a:prstGeom>
+          <a:noFill/>
+          <a:ln/>
+        </p:spPr>
+        <p:txBody>
+          <a:bodyPr wrap="square" lIns="0" tIns="0" rIns="0" bIns="0" rtlCol="0" anchor="ctr"/>
+          <a:lstStyle/>
+          <a:p>
+            <a:pPr algn="ctr">
+              <a:lnSpc>
+                <a:spcPct val="135000"/>
+              </a:lnSpc>
+            </a:pPr>
+            <a:r>
+              <a:rPr lang="en-US" altLang="ko-KR" sz="2600" i="1" dirty="0" err="1">
+                <a:solidFill>
+                  <a:srgbClr val="FFFFFF"/>
+                </a:solidFill>
+                <a:latin typeface="Cambria" pitchFamily="34" charset="0"/>
+                <a:ea typeface="Cambria" pitchFamily="34" charset="-122"/>
+                <a:cs typeface="Cambria" pitchFamily="34" charset="-120"/>
+              </a:rPr>
+              <a:t>진료실</a:t>
+            </a:r>
+            <a:r>
+              <a:rPr lang="ko-KR" altLang="en-US" sz="2600" i="1" dirty="0">
+                <a:solidFill>
+                  <a:srgbClr val="FFFFFF"/>
+                </a:solidFill>
+                <a:latin typeface="Cambria" pitchFamily="34" charset="0"/>
+                <a:ea typeface="Cambria" pitchFamily="34" charset="-122"/>
+                <a:cs typeface="Cambria" pitchFamily="34" charset="-120"/>
+              </a:rPr>
+              <a:t> </a:t>
+            </a:r>
+            <a:r>
+              <a:rPr lang="en-US" altLang="ko-KR" sz="2600" i="1" dirty="0">
+                <a:solidFill>
+                  <a:srgbClr val="FFFFFF"/>
+                </a:solidFill>
+                <a:latin typeface="Cambria" pitchFamily="34" charset="0"/>
+                <a:ea typeface="Cambria" pitchFamily="34" charset="-122"/>
+                <a:cs typeface="Cambria" pitchFamily="34" charset="-120"/>
+              </a:rPr>
+              <a:t>2</a:t>
+            </a:r>
+            <a:r>
+              <a:rPr lang="ko-KR" altLang="en-US" sz="2600" i="1" dirty="0">
+                <a:solidFill>
+                  <a:srgbClr val="FFFFFF"/>
+                </a:solidFill>
+                <a:latin typeface="Cambria" pitchFamily="34" charset="0"/>
+                <a:ea typeface="Cambria" pitchFamily="34" charset="-122"/>
+                <a:cs typeface="Cambria" pitchFamily="34" charset="-120"/>
+              </a:rPr>
+              <a:t>번에서 졸린 눈을 </a:t>
+            </a:r>
+            <a:r>
+              <a:rPr lang="ko-KR" altLang="en-US" sz="2600" i="1" dirty="0" err="1">
+                <a:solidFill>
+                  <a:srgbClr val="FFFFFF"/>
+                </a:solidFill>
+                <a:latin typeface="Cambria" pitchFamily="34" charset="0"/>
+                <a:ea typeface="Cambria" pitchFamily="34" charset="-122"/>
+                <a:cs typeface="Cambria" pitchFamily="34" charset="-120"/>
+              </a:rPr>
+              <a:t>부비고</a:t>
+            </a:r>
+            <a:r>
+              <a:rPr lang="ko-KR" altLang="en-US" sz="2600" i="1" dirty="0">
+                <a:solidFill>
+                  <a:srgbClr val="FFFFFF"/>
+                </a:solidFill>
+                <a:latin typeface="Cambria" pitchFamily="34" charset="0"/>
+                <a:ea typeface="Cambria" pitchFamily="34" charset="-122"/>
+                <a:cs typeface="Cambria" pitchFamily="34" charset="-120"/>
+              </a:rPr>
+              <a:t> 있을 때</a:t>
+            </a:r>
+            <a:r>
+              <a:rPr lang="en-US" altLang="ko-KR" sz="2600" i="1" dirty="0">
+                <a:solidFill>
+                  <a:srgbClr val="FFFFFF"/>
+                </a:solidFill>
+                <a:latin typeface="Cambria" pitchFamily="34" charset="0"/>
+                <a:ea typeface="Cambria" pitchFamily="34" charset="-122"/>
+                <a:cs typeface="Cambria" pitchFamily="34" charset="-120"/>
+              </a:rPr>
+              <a:t>,</a:t>
+            </a:r>
+            <a:r>
+              <a:rPr lang="ko-KR" altLang="en-US" sz="2600" i="1" dirty="0">
+                <a:solidFill>
+                  <a:srgbClr val="FFFFFF"/>
+                </a:solidFill>
+                <a:latin typeface="Cambria" pitchFamily="34" charset="0"/>
+                <a:ea typeface="Cambria" pitchFamily="34" charset="-122"/>
+                <a:cs typeface="Cambria" pitchFamily="34" charset="-120"/>
+              </a:rPr>
+              <a:t> </a:t>
+            </a:r>
+            <a:endParaRPr lang="en-US" altLang="ko-KR" sz="2600" i="1" dirty="0">
+              <a:solidFill>
+                <a:srgbClr val="FFFFFF"/>
+              </a:solidFill>
+              <a:latin typeface="Cambria" pitchFamily="34" charset="0"/>
+              <a:ea typeface="Cambria" pitchFamily="34" charset="-122"/>
+              <a:cs typeface="Cambria" pitchFamily="34" charset="-120"/>
+            </a:endParaRPr>
+          </a:p>
+          <a:p>
+            <a:pPr marL="0" indent="0" algn="ctr">
+              <a:lnSpc>
+                <a:spcPct val="135000"/>
+              </a:lnSpc>
+              <a:buNone/>
+            </a:pPr>
+            <a:r>
+              <a:rPr lang="ko-KR" altLang="en-US" sz="2600" i="1" dirty="0">
+                <a:solidFill>
+                  <a:srgbClr val="FFFFFF"/>
+                </a:solidFill>
+                <a:latin typeface="Cambria" pitchFamily="34" charset="0"/>
+                <a:ea typeface="Cambria" pitchFamily="34" charset="-122"/>
+                <a:cs typeface="Cambria" pitchFamily="34" charset="-120"/>
+              </a:rPr>
+              <a:t> </a:t>
+            </a:r>
+            <a:r>
+              <a:rPr lang="en-US" sz="2600" i="1" dirty="0" err="1">
+                <a:solidFill>
+                  <a:srgbClr val="FFFFFF"/>
+                </a:solidFill>
+                <a:latin typeface="Cambria" pitchFamily="34" charset="0"/>
+                <a:ea typeface="Cambria" pitchFamily="34" charset="-122"/>
+                <a:cs typeface="Cambria" pitchFamily="34" charset="-120"/>
+              </a:rPr>
+              <a:t>간호사가</a:t>
+            </a:r>
+            <a:r>
+              <a:rPr lang="en-US" sz="2600" i="1" dirty="0">
+                <a:solidFill>
+                  <a:srgbClr val="FFFFFF"/>
+                </a:solidFill>
+                <a:latin typeface="Cambria" pitchFamily="34" charset="0"/>
+                <a:ea typeface="Cambria" pitchFamily="34" charset="-122"/>
+                <a:cs typeface="Cambria" pitchFamily="34" charset="-120"/>
+              </a:rPr>
+              <a:t> </a:t>
+            </a:r>
+            <a:r>
+              <a:rPr lang="en-US" sz="2600" i="1" dirty="0" err="1">
+                <a:solidFill>
+                  <a:srgbClr val="FFFFFF"/>
+                </a:solidFill>
+                <a:latin typeface="Cambria" pitchFamily="34" charset="0"/>
+                <a:ea typeface="Cambria" pitchFamily="34" charset="-122"/>
+                <a:cs typeface="Cambria" pitchFamily="34" charset="-120"/>
+              </a:rPr>
+              <a:t>다급히</a:t>
+            </a:r>
+            <a:r>
+              <a:rPr lang="en-US" sz="2600" i="1" dirty="0">
+                <a:solidFill>
+                  <a:srgbClr val="FFFFFF"/>
+                </a:solidFill>
+                <a:latin typeface="Cambria" pitchFamily="34" charset="0"/>
+                <a:ea typeface="Cambria" pitchFamily="34" charset="-122"/>
+                <a:cs typeface="Cambria" pitchFamily="34" charset="-120"/>
+              </a:rPr>
+              <a:t> </a:t>
+            </a:r>
+            <a:r>
+              <a:rPr lang="ko-KR" altLang="en-US" sz="2600" i="1" dirty="0">
+                <a:solidFill>
+                  <a:srgbClr val="FFFFFF"/>
+                </a:solidFill>
+                <a:latin typeface="Cambria" pitchFamily="34" charset="0"/>
+                <a:ea typeface="Cambria" pitchFamily="34" charset="-122"/>
+                <a:cs typeface="Cambria" pitchFamily="34" charset="-120"/>
+              </a:rPr>
+              <a:t> 진료실 문을 두드린다</a:t>
+            </a:r>
+            <a:endParaRPr lang="en-US" sz="2600" dirty="0"/>
+          </a:p>
+        </p:txBody>
+      </p:sp>
+    </p:spTree>
+  </p:cSld>
+  <p:clrMapOvr>
+    <a:masterClrMapping/>
+  </p:clrMapOvr>
+</p:sld>
+</file>
+
+<file path=ppt/slides/slide8.xml><?xml version="1.0" encoding="utf-8"?>
+<p:sld xmlns:a="http://schemas.openxmlformats.org/drawingml/2006/main" xmlns:r="http://schemas.openxmlformats.org/officeDocument/2006/relationships" xmlns:p="http://schemas.openxmlformats.org/presentationml/2006/main">
   <p:cSld name="Slide 21">
     <p:bg>
       <p:bgPr>
@@ -6663,7 +7764,7 @@
 </p:sld>
 </file>
 
-<file path=ppt/slides/slide4.xml><?xml version="1.0" encoding="utf-8"?>
+<file path=ppt/slides/slide9.xml><?xml version="1.0" encoding="utf-8"?>
 <p:sld xmlns:a="http://schemas.openxmlformats.org/drawingml/2006/main" xmlns:r="http://schemas.openxmlformats.org/officeDocument/2006/relationships" xmlns:p="http://schemas.openxmlformats.org/presentationml/2006/main">
   <p:cSld>
     <p:bg>
@@ -7056,1074 +8157,6 @@
                 </p:cTn>
                 <p:tgtEl>
                   <p:spTgt spid="25"/>
-                </p:tgtEl>
-              </p:cMediaNode>
-            </p:audio>
-          </p:childTnLst>
-        </p:cTn>
-      </p:par>
-    </p:tnLst>
-  </p:timing>
-</p:sld>
-</file>
-
-<file path=ppt/slides/slide5.xml><?xml version="1.0" encoding="utf-8"?>
-<p:sld xmlns:a="http://schemas.openxmlformats.org/drawingml/2006/main" xmlns:r="http://schemas.openxmlformats.org/officeDocument/2006/relationships" xmlns:p="http://schemas.openxmlformats.org/presentationml/2006/main">
-  <p:cSld name="Slide 23">
-    <p:bg>
-      <p:bgPr>
-        <a:solidFill>
-          <a:srgbClr val="3A0A22"/>
-        </a:solidFill>
-        <a:effectLst/>
-      </p:bgPr>
-    </p:bg>
-    <p:spTree>
-      <p:nvGrpSpPr>
-        <p:cNvPr id="1" name=""/>
-        <p:cNvGrpSpPr/>
-        <p:nvPr/>
-      </p:nvGrpSpPr>
-      <p:grpSpPr>
-        <a:xfrm>
-          <a:off x="0" y="0"/>
-          <a:ext cx="0" cy="0"/>
-          <a:chOff x="0" y="0"/>
-          <a:chExt cx="0" cy="0"/>
-        </a:xfrm>
-      </p:grpSpPr>
-      <p:sp>
-        <p:nvSpPr>
-          <p:cNvPr id="3" name="Text 1"/>
-          <p:cNvSpPr/>
-          <p:nvPr/>
-        </p:nvSpPr>
-        <p:spPr>
-          <a:xfrm>
-            <a:off x="1280160" y="2468880"/>
-            <a:ext cx="9631375" cy="1920240"/>
-          </a:xfrm>
-          <a:prstGeom prst="rect">
-            <a:avLst/>
-          </a:prstGeom>
-          <a:noFill/>
-          <a:ln/>
-        </p:spPr>
-        <p:txBody>
-          <a:bodyPr wrap="square" lIns="0" tIns="0" rIns="0" bIns="0" rtlCol="0" anchor="ctr"/>
-          <a:lstStyle/>
-          <a:p>
-            <a:pPr marL="0" indent="0" algn="ctr">
-              <a:lnSpc>
-                <a:spcPct val="135000"/>
-              </a:lnSpc>
-              <a:buNone/>
-            </a:pPr>
-            <a:r>
-              <a:rPr lang="en-US" sz="2600" i="1" dirty="0">
-                <a:solidFill>
-                  <a:srgbClr val="FFFFFF"/>
-                </a:solidFill>
-                <a:latin typeface="Cambria" pitchFamily="34" charset="0"/>
-                <a:ea typeface="Cambria" pitchFamily="34" charset="-122"/>
-                <a:cs typeface="Cambria" pitchFamily="34" charset="-120"/>
-              </a:rPr>
-              <a:t>처치실로 들어서자 아이는 침대에 늘어져 있다. 평소라면 낯선 사람을 보고 울었을 아이지만, 지금은 눈을 뜨는 것조차 힘겨워 보인다.</a:t>
-            </a:r>
-            <a:endParaRPr lang="en-US" sz="2600" dirty="0"/>
-          </a:p>
-          <a:p>
-            <a:pPr marL="0" indent="0" algn="ctr">
-              <a:lnSpc>
-                <a:spcPct val="135000"/>
-              </a:lnSpc>
-              <a:buNone/>
-            </a:pPr>
-            <a:endParaRPr lang="en-US" sz="2600" dirty="0"/>
-          </a:p>
-          <a:p>
-            <a:pPr marL="0" indent="0" algn="ctr">
-              <a:lnSpc>
-                <a:spcPct val="135000"/>
-              </a:lnSpc>
-              <a:buNone/>
-            </a:pPr>
-            <a:r>
-              <a:rPr lang="en-US" sz="2600" i="1" dirty="0">
-                <a:solidFill>
-                  <a:srgbClr val="FFFFFF"/>
-                </a:solidFill>
-                <a:latin typeface="Cambria" pitchFamily="34" charset="0"/>
-                <a:ea typeface="Cambria" pitchFamily="34" charset="-122"/>
-                <a:cs typeface="Cambria" pitchFamily="34" charset="-120"/>
-              </a:rPr>
-              <a:t>항암치료 중이라는 병력이 머릿속에 경고음을 울리고, </a:t>
-            </a:r>
-          </a:p>
-          <a:p>
-            <a:pPr marL="0" indent="0" algn="ctr">
-              <a:lnSpc>
-                <a:spcPct val="135000"/>
-              </a:lnSpc>
-              <a:buNone/>
-            </a:pPr>
-            <a:r>
-              <a:rPr lang="en-US" sz="2600" i="1" dirty="0" err="1">
-                <a:solidFill>
-                  <a:srgbClr val="FFFFFF"/>
-                </a:solidFill>
-                <a:latin typeface="Cambria" pitchFamily="34" charset="0"/>
-                <a:ea typeface="Cambria" pitchFamily="34" charset="-122"/>
-                <a:cs typeface="Cambria" pitchFamily="34" charset="-120"/>
-              </a:rPr>
-              <a:t>당신은</a:t>
-            </a:r>
-            <a:r>
-              <a:rPr lang="en-US" sz="2600" i="1" dirty="0">
-                <a:solidFill>
-                  <a:srgbClr val="FFFFFF"/>
-                </a:solidFill>
-                <a:latin typeface="Cambria" pitchFamily="34" charset="0"/>
-                <a:ea typeface="Cambria" pitchFamily="34" charset="-122"/>
-                <a:cs typeface="Cambria" pitchFamily="34" charset="-120"/>
-              </a:rPr>
-              <a:t> 곧바로 치프 </a:t>
-            </a:r>
-            <a:r>
-              <a:rPr lang="en-US" sz="2600" i="1" dirty="0" err="1">
-                <a:solidFill>
-                  <a:srgbClr val="FFFFFF"/>
-                </a:solidFill>
-                <a:latin typeface="Cambria" pitchFamily="34" charset="0"/>
-                <a:ea typeface="Cambria" pitchFamily="34" charset="-122"/>
-                <a:cs typeface="Cambria" pitchFamily="34" charset="-120"/>
-              </a:rPr>
-              <a:t>당직과</a:t>
-            </a:r>
-            <a:r>
-              <a:rPr lang="en-US" sz="2600" i="1" dirty="0">
-                <a:solidFill>
-                  <a:srgbClr val="FFFFFF"/>
-                </a:solidFill>
-                <a:latin typeface="Cambria" pitchFamily="34" charset="0"/>
-                <a:ea typeface="Cambria" pitchFamily="34" charset="-122"/>
-                <a:cs typeface="Cambria" pitchFamily="34" charset="-120"/>
-              </a:rPr>
-              <a:t> </a:t>
-            </a:r>
-            <a:r>
-              <a:rPr lang="en-US" sz="2600" i="1" dirty="0" err="1">
-                <a:solidFill>
-                  <a:srgbClr val="FFFFFF"/>
-                </a:solidFill>
-                <a:latin typeface="Cambria" pitchFamily="34" charset="0"/>
-                <a:ea typeface="Cambria" pitchFamily="34" charset="-122"/>
-                <a:cs typeface="Cambria" pitchFamily="34" charset="-120"/>
-              </a:rPr>
-              <a:t>중환자실</a:t>
-            </a:r>
-            <a:r>
-              <a:rPr lang="ko-KR" altLang="en-US" sz="2600" i="1" dirty="0">
-                <a:solidFill>
-                  <a:srgbClr val="FFFFFF"/>
-                </a:solidFill>
-                <a:latin typeface="Cambria" pitchFamily="34" charset="0"/>
-                <a:ea typeface="Cambria" pitchFamily="34" charset="-122"/>
-                <a:cs typeface="Cambria" pitchFamily="34" charset="-120"/>
-              </a:rPr>
-              <a:t> </a:t>
-            </a:r>
-            <a:r>
-              <a:rPr lang="en-US" sz="2600" i="1" dirty="0" err="1">
-                <a:solidFill>
-                  <a:srgbClr val="FFFFFF"/>
-                </a:solidFill>
-                <a:latin typeface="Cambria" pitchFamily="34" charset="0"/>
-                <a:ea typeface="Cambria" pitchFamily="34" charset="-122"/>
-                <a:cs typeface="Cambria" pitchFamily="34" charset="-120"/>
-              </a:rPr>
-              <a:t>당직을</a:t>
-            </a:r>
-            <a:r>
-              <a:rPr lang="en-US" sz="2600" i="1" dirty="0">
-                <a:solidFill>
-                  <a:srgbClr val="FFFFFF"/>
-                </a:solidFill>
-                <a:latin typeface="Cambria" pitchFamily="34" charset="0"/>
-                <a:ea typeface="Cambria" pitchFamily="34" charset="-122"/>
-                <a:cs typeface="Cambria" pitchFamily="34" charset="-120"/>
-              </a:rPr>
-              <a:t> 부른다.</a:t>
-            </a:r>
-            <a:endParaRPr lang="en-US" sz="2600" dirty="0"/>
-          </a:p>
-        </p:txBody>
-      </p:sp>
-    </p:spTree>
-  </p:cSld>
-  <p:clrMapOvr>
-    <a:masterClrMapping/>
-  </p:clrMapOvr>
-  <mc:AlternateContent xmlns:mc="http://schemas.openxmlformats.org/markup-compatibility/2006">
-    <mc:Choice xmlns:p14="http://schemas.microsoft.com/office/powerpoint/2010/main" Requires="p14">
-      <p:transition spd="slow" p14:dur="2000" advTm="8638"/>
-    </mc:Choice>
-    <mc:Fallback>
-      <p:transition spd="slow" advTm="8638"/>
-    </mc:Fallback>
-  </mc:AlternateContent>
-</p:sld>
-</file>
-
-<file path=ppt/slides/slide6.xml><?xml version="1.0" encoding="utf-8"?>
-<p:sld xmlns:a="http://schemas.openxmlformats.org/drawingml/2006/main" xmlns:r="http://schemas.openxmlformats.org/officeDocument/2006/relationships" xmlns:p="http://schemas.openxmlformats.org/presentationml/2006/main">
-  <p:cSld name="Slide 24">
-    <p:bg>
-      <p:bgPr>
-        <a:solidFill>
-          <a:srgbClr val="9A1750"/>
-        </a:solidFill>
-        <a:effectLst/>
-      </p:bgPr>
-    </p:bg>
-    <p:spTree>
-      <p:nvGrpSpPr>
-        <p:cNvPr id="1" name=""/>
-        <p:cNvGrpSpPr/>
-        <p:nvPr/>
-      </p:nvGrpSpPr>
-      <p:grpSpPr>
-        <a:xfrm>
-          <a:off x="0" y="0"/>
-          <a:ext cx="0" cy="0"/>
-          <a:chOff x="0" y="0"/>
-          <a:chExt cx="0" cy="0"/>
-        </a:xfrm>
-      </p:grpSpPr>
-      <p:pic>
-        <p:nvPicPr>
-          <p:cNvPr id="3" name="Image 0" descr="preencoded.png"/>
-          <p:cNvPicPr>
-            <a:picLocks noChangeAspect="1"/>
-          </p:cNvPicPr>
-          <p:nvPr/>
-        </p:nvPicPr>
-        <p:blipFill>
-          <a:blip r:embed="rId3"/>
-          <a:stretch>
-            <a:fillRect/>
-          </a:stretch>
-        </p:blipFill>
-        <p:spPr>
-          <a:xfrm>
-            <a:off x="5730088" y="1920240"/>
-            <a:ext cx="731520" cy="731520"/>
-          </a:xfrm>
-          <a:prstGeom prst="rect">
-            <a:avLst/>
-          </a:prstGeom>
-        </p:spPr>
-      </p:pic>
-      <p:sp>
-        <p:nvSpPr>
-          <p:cNvPr id="4" name="Text 1"/>
-          <p:cNvSpPr/>
-          <p:nvPr/>
-        </p:nvSpPr>
-        <p:spPr>
-          <a:xfrm>
-            <a:off x="1188720" y="2880360"/>
-            <a:ext cx="9814255" cy="1371600"/>
-          </a:xfrm>
-          <a:prstGeom prst="rect">
-            <a:avLst/>
-          </a:prstGeom>
-          <a:noFill/>
-          <a:ln/>
-        </p:spPr>
-        <p:txBody>
-          <a:bodyPr wrap="square" lIns="0" tIns="0" rIns="0" bIns="0" rtlCol="0" anchor="ctr"/>
-          <a:lstStyle/>
-          <a:p>
-            <a:pPr marL="0" indent="0" algn="ctr">
-              <a:lnSpc>
-                <a:spcPct val="120000"/>
-              </a:lnSpc>
-              <a:buNone/>
-            </a:pPr>
-            <a:r>
-              <a:rPr lang="en-US" sz="3000" b="1" dirty="0">
-                <a:solidFill>
-                  <a:srgbClr val="FFFFFF"/>
-                </a:solidFill>
-                <a:latin typeface="Cambria" pitchFamily="34" charset="0"/>
-                <a:ea typeface="Cambria" pitchFamily="34" charset="-122"/>
-                <a:cs typeface="Cambria" pitchFamily="34" charset="-120"/>
-              </a:rPr>
-              <a:t>함께 환자를 평가하고</a:t>
-            </a:r>
-            <a:endParaRPr lang="en-US" sz="3000" dirty="0"/>
-          </a:p>
-          <a:p>
-            <a:pPr marL="0" indent="0" algn="ctr">
-              <a:lnSpc>
-                <a:spcPct val="120000"/>
-              </a:lnSpc>
-              <a:buNone/>
-            </a:pPr>
-            <a:r>
-              <a:rPr lang="en-US" sz="3000" b="1" dirty="0">
-                <a:solidFill>
-                  <a:srgbClr val="FFFFFF"/>
-                </a:solidFill>
-                <a:latin typeface="Cambria" pitchFamily="34" charset="0"/>
-                <a:ea typeface="Cambria" pitchFamily="34" charset="-122"/>
-                <a:cs typeface="Cambria" pitchFamily="34" charset="-120"/>
-              </a:rPr>
-              <a:t>적절한 진단과 치료 방침을 세우시오.</a:t>
-            </a:r>
-            <a:endParaRPr lang="en-US" sz="3000" dirty="0"/>
-          </a:p>
-        </p:txBody>
-      </p:sp>
-    </p:spTree>
-  </p:cSld>
-  <p:clrMapOvr>
-    <a:masterClrMapping/>
-  </p:clrMapOvr>
-</p:sld>
-</file>
-
-<file path=ppt/slides/slide7.xml><?xml version="1.0" encoding="utf-8"?>
-<p:sld xmlns:a="http://schemas.openxmlformats.org/drawingml/2006/main" xmlns:r="http://schemas.openxmlformats.org/officeDocument/2006/relationships" xmlns:p="http://schemas.openxmlformats.org/presentationml/2006/main">
-  <p:cSld name="Slide 7">
-    <p:bg>
-      <p:bgPr>
-        <a:solidFill>
-          <a:srgbClr val="3D1509"/>
-        </a:solidFill>
-        <a:effectLst/>
-      </p:bgPr>
-    </p:bg>
-    <p:spTree>
-      <p:nvGrpSpPr>
-        <p:cNvPr id="1" name=""/>
-        <p:cNvGrpSpPr/>
-        <p:nvPr/>
-      </p:nvGrpSpPr>
-      <p:grpSpPr>
-        <a:xfrm>
-          <a:off x="0" y="0"/>
-          <a:ext cx="0" cy="0"/>
-          <a:chOff x="0" y="0"/>
-          <a:chExt cx="0" cy="0"/>
-        </a:xfrm>
-      </p:grpSpPr>
-      <p:pic>
-        <p:nvPicPr>
-          <p:cNvPr id="3" name="Image 0" descr="preencoded.png"/>
-          <p:cNvPicPr>
-            <a:picLocks noChangeAspect="1"/>
-          </p:cNvPicPr>
-          <p:nvPr/>
-        </p:nvPicPr>
-        <p:blipFill>
-          <a:blip r:embed="rId3"/>
-          <a:stretch>
-            <a:fillRect/>
-          </a:stretch>
-        </p:blipFill>
-        <p:spPr>
-          <a:xfrm>
-            <a:off x="5684368" y="1691640"/>
-            <a:ext cx="822960" cy="822960"/>
-          </a:xfrm>
-          <a:prstGeom prst="rect">
-            <a:avLst/>
-          </a:prstGeom>
-        </p:spPr>
-      </p:pic>
-      <p:sp>
-        <p:nvSpPr>
-          <p:cNvPr id="4" name="Text 1"/>
-          <p:cNvSpPr/>
-          <p:nvPr/>
-        </p:nvSpPr>
-        <p:spPr>
-          <a:xfrm>
-            <a:off x="914400" y="2743200"/>
-            <a:ext cx="10362895" cy="1188720"/>
-          </a:xfrm>
-          <a:prstGeom prst="rect">
-            <a:avLst/>
-          </a:prstGeom>
-          <a:noFill/>
-          <a:ln/>
-        </p:spPr>
-        <p:txBody>
-          <a:bodyPr wrap="square" lIns="0" tIns="0" rIns="0" bIns="0" rtlCol="0" anchor="ctr"/>
-          <a:lstStyle/>
-          <a:p>
-            <a:pPr marL="0" indent="0" algn="ctr">
-              <a:buNone/>
-            </a:pPr>
-            <a:r>
-              <a:rPr lang="en-US" sz="5800" b="1" dirty="0">
-                <a:solidFill>
-                  <a:srgbClr val="FFFFFF"/>
-                </a:solidFill>
-                <a:latin typeface="Cambria" pitchFamily="34" charset="0"/>
-                <a:ea typeface="Cambria" pitchFamily="34" charset="-122"/>
-                <a:cs typeface="Cambria" pitchFamily="34" charset="-120"/>
-              </a:rPr>
-              <a:t>새벽 2시</a:t>
-            </a:r>
-            <a:endParaRPr lang="en-US" sz="5800" dirty="0"/>
-          </a:p>
-        </p:txBody>
-      </p:sp>
-      <p:sp>
-        <p:nvSpPr>
-          <p:cNvPr id="5" name="Text 2"/>
-          <p:cNvSpPr/>
-          <p:nvPr/>
-        </p:nvSpPr>
-        <p:spPr>
-          <a:xfrm>
-            <a:off x="914400" y="3886200"/>
-            <a:ext cx="10362895" cy="365760"/>
-          </a:xfrm>
-          <a:prstGeom prst="rect">
-            <a:avLst/>
-          </a:prstGeom>
-          <a:noFill/>
-          <a:ln/>
-        </p:spPr>
-        <p:txBody>
-          <a:bodyPr wrap="square" lIns="0" tIns="0" rIns="0" bIns="0" rtlCol="0" anchor="ctr"/>
-          <a:lstStyle/>
-          <a:p>
-            <a:pPr marL="0" indent="0" algn="ctr">
-              <a:buNone/>
-            </a:pPr>
-            <a:r>
-              <a:rPr lang="en-US" sz="1400" b="1" kern="0" spc="300" dirty="0" err="1">
-                <a:solidFill>
-                  <a:srgbClr val="F0C4AE"/>
-                </a:solidFill>
-                <a:latin typeface="Calibri" pitchFamily="34" charset="0"/>
-                <a:ea typeface="Calibri" pitchFamily="34" charset="-122"/>
-                <a:cs typeface="Calibri" pitchFamily="34" charset="-120"/>
-              </a:rPr>
-              <a:t>소아응급의료센터</a:t>
-            </a:r>
-            <a:endParaRPr lang="en-US" sz="1400" dirty="0"/>
-          </a:p>
-        </p:txBody>
-      </p:sp>
-    </p:spTree>
-  </p:cSld>
-  <p:clrMapOvr>
-    <a:masterClrMapping/>
-  </p:clrMapOvr>
-</p:sld>
-</file>
-
-<file path=ppt/slides/slide8.xml><?xml version="1.0" encoding="utf-8"?>
-<p:sld xmlns:a="http://schemas.openxmlformats.org/drawingml/2006/main" xmlns:r="http://schemas.openxmlformats.org/officeDocument/2006/relationships" xmlns:p="http://schemas.openxmlformats.org/presentationml/2006/main">
-  <p:cSld name="Slide 8">
-    <p:bg>
-      <p:bgPr>
-        <a:solidFill>
-          <a:srgbClr val="3D1509"/>
-        </a:solidFill>
-        <a:effectLst/>
-      </p:bgPr>
-    </p:bg>
-    <p:spTree>
-      <p:nvGrpSpPr>
-        <p:cNvPr id="1" name=""/>
-        <p:cNvGrpSpPr/>
-        <p:nvPr/>
-      </p:nvGrpSpPr>
-      <p:grpSpPr>
-        <a:xfrm>
-          <a:off x="0" y="0"/>
-          <a:ext cx="0" cy="0"/>
-          <a:chOff x="0" y="0"/>
-          <a:chExt cx="0" cy="0"/>
-        </a:xfrm>
-      </p:grpSpPr>
-      <p:sp>
-        <p:nvSpPr>
-          <p:cNvPr id="3" name="Text 1"/>
-          <p:cNvSpPr/>
-          <p:nvPr/>
-        </p:nvSpPr>
-        <p:spPr>
-          <a:xfrm>
-            <a:off x="1280160" y="2468880"/>
-            <a:ext cx="9631375" cy="1920240"/>
-          </a:xfrm>
-          <a:prstGeom prst="rect">
-            <a:avLst/>
-          </a:prstGeom>
-          <a:noFill/>
-          <a:ln/>
-        </p:spPr>
-        <p:txBody>
-          <a:bodyPr wrap="square" lIns="0" tIns="0" rIns="0" bIns="0" rtlCol="0" anchor="ctr"/>
-          <a:lstStyle/>
-          <a:p>
-            <a:pPr marL="0" indent="0" algn="ctr">
-              <a:lnSpc>
-                <a:spcPct val="135000"/>
-              </a:lnSpc>
-              <a:buNone/>
-            </a:pPr>
-            <a:r>
-              <a:rPr lang="en-US" sz="2600" i="1" dirty="0" err="1">
-                <a:solidFill>
-                  <a:srgbClr val="FFFFFF"/>
-                </a:solidFill>
-                <a:latin typeface="Cambria" pitchFamily="34" charset="0"/>
-                <a:ea typeface="Cambria" pitchFamily="34" charset="-122"/>
-                <a:cs typeface="Cambria" pitchFamily="34" charset="-120"/>
-              </a:rPr>
-              <a:t>정적을</a:t>
-            </a:r>
-            <a:r>
-              <a:rPr lang="ko-KR" altLang="en-US" sz="2600" i="1" dirty="0">
-                <a:solidFill>
-                  <a:srgbClr val="FFFFFF"/>
-                </a:solidFill>
-                <a:latin typeface="Cambria" pitchFamily="34" charset="0"/>
-                <a:ea typeface="Cambria" pitchFamily="34" charset="-122"/>
-                <a:cs typeface="Cambria" pitchFamily="34" charset="-120"/>
-              </a:rPr>
-              <a:t> 깨는 전화벨소리 전화기 </a:t>
-            </a:r>
-            <a:r>
-              <a:rPr lang="ko-KR" altLang="en-US" sz="2600" i="1" dirty="0" err="1">
-                <a:solidFill>
-                  <a:srgbClr val="FFFFFF"/>
-                </a:solidFill>
-                <a:latin typeface="Cambria" pitchFamily="34" charset="0"/>
-                <a:ea typeface="Cambria" pitchFamily="34" charset="-122"/>
-                <a:cs typeface="Cambria" pitchFamily="34" charset="-120"/>
-              </a:rPr>
-              <a:t>넘어로</a:t>
-            </a:r>
-            <a:r>
-              <a:rPr lang="ko-KR" altLang="en-US" sz="2600" i="1" dirty="0">
-                <a:solidFill>
-                  <a:srgbClr val="FFFFFF"/>
-                </a:solidFill>
-                <a:latin typeface="Cambria" pitchFamily="34" charset="0"/>
-                <a:ea typeface="Cambria" pitchFamily="34" charset="-122"/>
-                <a:cs typeface="Cambria" pitchFamily="34" charset="-120"/>
-              </a:rPr>
-              <a:t> </a:t>
-            </a:r>
-            <a:endParaRPr lang="en-US" altLang="ko-KR" sz="2600" i="1" dirty="0">
-              <a:solidFill>
-                <a:srgbClr val="FFFFFF"/>
-              </a:solidFill>
-              <a:latin typeface="Cambria" pitchFamily="34" charset="0"/>
-              <a:ea typeface="Cambria" pitchFamily="34" charset="-122"/>
-              <a:cs typeface="Cambria" pitchFamily="34" charset="-120"/>
-            </a:endParaRPr>
-          </a:p>
-          <a:p>
-            <a:pPr marL="0" indent="0" algn="ctr">
-              <a:lnSpc>
-                <a:spcPct val="135000"/>
-              </a:lnSpc>
-              <a:buNone/>
-            </a:pPr>
-            <a:r>
-              <a:rPr lang="en-US" sz="2600" i="1" dirty="0">
-                <a:solidFill>
-                  <a:srgbClr val="FFFFFF"/>
-                </a:solidFill>
-                <a:latin typeface="Cambria" pitchFamily="34" charset="0"/>
-                <a:ea typeface="Cambria" pitchFamily="34" charset="-122"/>
-                <a:cs typeface="Cambria" pitchFamily="34" charset="-120"/>
-              </a:rPr>
-              <a:t> 119 구급대의 다급한 무선 보고가 들어온다.</a:t>
-            </a:r>
-            <a:endParaRPr lang="en-US" sz="2600" dirty="0"/>
-          </a:p>
-        </p:txBody>
-      </p:sp>
-    </p:spTree>
-  </p:cSld>
-  <p:clrMapOvr>
-    <a:masterClrMapping/>
-  </p:clrMapOvr>
-</p:sld>
-</file>
-
-<file path=ppt/slides/slide9.xml><?xml version="1.0" encoding="utf-8"?>
-<p:sld xmlns:a="http://schemas.openxmlformats.org/drawingml/2006/main" xmlns:r="http://schemas.openxmlformats.org/officeDocument/2006/relationships" xmlns:p="http://schemas.openxmlformats.org/presentationml/2006/main">
-  <p:cSld name="Slide 9">
-    <p:bg>
-      <p:bgPr>
-        <a:solidFill>
-          <a:srgbClr val="3D1509"/>
-        </a:solidFill>
-        <a:effectLst/>
-      </p:bgPr>
-    </p:bg>
-    <p:spTree>
-      <p:nvGrpSpPr>
-        <p:cNvPr id="1" name=""/>
-        <p:cNvGrpSpPr/>
-        <p:nvPr/>
-      </p:nvGrpSpPr>
-      <p:grpSpPr>
-        <a:xfrm>
-          <a:off x="0" y="0"/>
-          <a:ext cx="0" cy="0"/>
-          <a:chOff x="0" y="0"/>
-          <a:chExt cx="0" cy="0"/>
-        </a:xfrm>
-      </p:grpSpPr>
-      <p:sp>
-        <p:nvSpPr>
-          <p:cNvPr id="6" name="Shape 3"/>
-          <p:cNvSpPr/>
-          <p:nvPr/>
-        </p:nvSpPr>
-        <p:spPr>
-          <a:xfrm>
-            <a:off x="640080" y="2697480"/>
-            <a:ext cx="10911535" cy="1828800"/>
-          </a:xfrm>
-          <a:prstGeom prst="roundRect">
-            <a:avLst>
-              <a:gd name="adj" fmla="val 7000"/>
-            </a:avLst>
-          </a:prstGeom>
-          <a:solidFill>
-            <a:srgbClr val="FFFFFF"/>
-          </a:solidFill>
-          <a:ln/>
-          <a:effectLst>
-            <a:outerShdw blurRad="127000" dist="38100" dir="5400000" algn="bl" rotWithShape="0">
-              <a:srgbClr val="1B2E2C">
-                <a:alpha val="12000"/>
-              </a:srgbClr>
-            </a:outerShdw>
-          </a:effectLst>
-        </p:spPr>
-        <p:txBody>
-          <a:bodyPr/>
-          <a:lstStyle/>
-          <a:p>
-            <a:endParaRPr lang="ko-KR" altLang="en-US" dirty="0"/>
-          </a:p>
-        </p:txBody>
-      </p:sp>
-      <p:pic>
-        <p:nvPicPr>
-          <p:cNvPr id="7" name="Image 1" descr="preencoded.png"/>
-          <p:cNvPicPr>
-            <a:picLocks noChangeAspect="1"/>
-          </p:cNvPicPr>
-          <p:nvPr/>
-        </p:nvPicPr>
-        <p:blipFill>
-          <a:blip r:embed="rId5"/>
-          <a:stretch>
-            <a:fillRect/>
-          </a:stretch>
-        </p:blipFill>
-        <p:spPr>
-          <a:xfrm>
-            <a:off x="1005840" y="2953512"/>
-            <a:ext cx="365760" cy="365760"/>
-          </a:xfrm>
-          <a:prstGeom prst="rect">
-            <a:avLst/>
-          </a:prstGeom>
-        </p:spPr>
-      </p:pic>
-      <p:sp>
-        <p:nvSpPr>
-          <p:cNvPr id="8" name="Text 4"/>
-          <p:cNvSpPr/>
-          <p:nvPr/>
-        </p:nvSpPr>
-        <p:spPr>
-          <a:xfrm>
-            <a:off x="1600200" y="2862072"/>
-            <a:ext cx="9585655" cy="1143000"/>
-          </a:xfrm>
-          <a:prstGeom prst="rect">
-            <a:avLst/>
-          </a:prstGeom>
-          <a:noFill/>
-          <a:ln/>
-        </p:spPr>
-        <p:txBody>
-          <a:bodyPr wrap="square" lIns="0" tIns="0" rIns="0" bIns="0" rtlCol="0" anchor="ctr"/>
-          <a:lstStyle/>
-          <a:p>
-            <a:pPr marL="0" indent="0">
-              <a:lnSpc>
-                <a:spcPct val="115000"/>
-              </a:lnSpc>
-              <a:buNone/>
-            </a:pPr>
-            <a:r>
-              <a:rPr lang="en-US" sz="2100" i="1" dirty="0">
-                <a:solidFill>
-                  <a:srgbClr val="13292A"/>
-                </a:solidFill>
-                <a:latin typeface="Cambria" pitchFamily="34" charset="0"/>
-                <a:ea typeface="Cambria" pitchFamily="34" charset="-122"/>
-                <a:cs typeface="Cambria" pitchFamily="34" charset="-120"/>
-              </a:rPr>
-              <a:t>6세 </a:t>
-            </a:r>
-            <a:r>
-              <a:rPr lang="ko-KR" altLang="en-US" sz="2100" i="1" dirty="0">
-                <a:solidFill>
-                  <a:srgbClr val="13292A"/>
-                </a:solidFill>
-                <a:latin typeface="Cambria" pitchFamily="34" charset="0"/>
-                <a:ea typeface="Cambria" pitchFamily="34" charset="-122"/>
-                <a:cs typeface="Cambria" pitchFamily="34" charset="-120"/>
-              </a:rPr>
-              <a:t> 여아 보행자  </a:t>
-            </a:r>
-            <a:r>
-              <a:rPr lang="en-US" altLang="ko-KR" sz="2100" i="1" dirty="0">
-                <a:solidFill>
-                  <a:srgbClr val="13292A"/>
-                </a:solidFill>
-                <a:latin typeface="Cambria" pitchFamily="34" charset="0"/>
-                <a:ea typeface="Cambria" pitchFamily="34" charset="-122"/>
-                <a:cs typeface="Cambria" pitchFamily="34" charset="-120"/>
-              </a:rPr>
-              <a:t>TA</a:t>
-            </a:r>
-            <a:r>
-              <a:rPr lang="ko-KR" altLang="en-US" sz="2100" i="1" dirty="0">
-                <a:solidFill>
-                  <a:srgbClr val="13292A"/>
-                </a:solidFill>
-                <a:latin typeface="Cambria" pitchFamily="34" charset="0"/>
-                <a:ea typeface="Cambria" pitchFamily="34" charset="-122"/>
-                <a:cs typeface="Cambria" pitchFamily="34" charset="-120"/>
-              </a:rPr>
-              <a:t>입니다</a:t>
-            </a:r>
-            <a:r>
-              <a:rPr lang="en-US" sz="2100" i="1" dirty="0">
-                <a:solidFill>
-                  <a:srgbClr val="13292A"/>
-                </a:solidFill>
-                <a:latin typeface="Cambria" pitchFamily="34" charset="0"/>
-                <a:ea typeface="Cambria" pitchFamily="34" charset="-122"/>
-                <a:cs typeface="Cambria" pitchFamily="34" charset="-120"/>
-              </a:rPr>
-              <a:t>.</a:t>
-            </a:r>
-            <a:r>
-              <a:rPr lang="ko-KR" altLang="en-US" sz="2100" i="1" dirty="0">
-                <a:solidFill>
-                  <a:srgbClr val="13292A"/>
-                </a:solidFill>
-                <a:latin typeface="Cambria" pitchFamily="34" charset="0"/>
-                <a:ea typeface="Cambria" pitchFamily="34" charset="-122"/>
-                <a:cs typeface="Cambria" pitchFamily="34" charset="-120"/>
-              </a:rPr>
-              <a:t> 지나가던 행인에 의해 신고되었고 보호자 연락은 돼서 </a:t>
-            </a:r>
-            <a:r>
-              <a:rPr lang="ko-KR" altLang="en-US" sz="2100" i="1" dirty="0" err="1">
-                <a:solidFill>
-                  <a:srgbClr val="13292A"/>
-                </a:solidFill>
-                <a:latin typeface="Cambria" pitchFamily="34" charset="0"/>
-                <a:ea typeface="Cambria" pitchFamily="34" charset="-122"/>
-                <a:cs typeface="Cambria" pitchFamily="34" charset="-120"/>
-              </a:rPr>
-              <a:t>오고계십니다</a:t>
-            </a:r>
-            <a:r>
-              <a:rPr lang="en-US" altLang="ko-KR" sz="2100" i="1" dirty="0">
-                <a:solidFill>
-                  <a:srgbClr val="13292A"/>
-                </a:solidFill>
-                <a:latin typeface="Cambria" pitchFamily="34" charset="0"/>
-                <a:ea typeface="Cambria" pitchFamily="34" charset="-122"/>
-                <a:cs typeface="Cambria" pitchFamily="34" charset="-120"/>
-              </a:rPr>
-              <a:t>.</a:t>
-            </a:r>
-            <a:r>
-              <a:rPr lang="ko-KR" altLang="en-US" sz="2100" i="1" dirty="0">
-                <a:solidFill>
-                  <a:srgbClr val="13292A"/>
-                </a:solidFill>
-                <a:latin typeface="Cambria" pitchFamily="34" charset="0"/>
-                <a:ea typeface="Cambria" pitchFamily="34" charset="-122"/>
-                <a:cs typeface="Cambria" pitchFamily="34" charset="-120"/>
-              </a:rPr>
-              <a:t> </a:t>
-            </a:r>
-            <a:r>
-              <a:rPr lang="ko-KR" altLang="en-US" sz="2100" i="1" dirty="0" err="1">
-                <a:solidFill>
-                  <a:srgbClr val="13292A"/>
-                </a:solidFill>
-                <a:latin typeface="Cambria" pitchFamily="34" charset="0"/>
-                <a:ea typeface="Cambria" pitchFamily="34" charset="-122"/>
-                <a:cs typeface="Cambria" pitchFamily="34" charset="-120"/>
-              </a:rPr>
-              <a:t>멘탈이</a:t>
-            </a:r>
-            <a:r>
-              <a:rPr lang="ko-KR" altLang="en-US" sz="2100" i="1" dirty="0">
-                <a:solidFill>
-                  <a:srgbClr val="13292A"/>
-                </a:solidFill>
-                <a:latin typeface="Cambria" pitchFamily="34" charset="0"/>
-                <a:ea typeface="Cambria" pitchFamily="34" charset="-122"/>
-                <a:cs typeface="Cambria" pitchFamily="34" charset="-120"/>
-              </a:rPr>
-              <a:t> 약간 쳐지고 있는데 수용 가능할까요</a:t>
-            </a:r>
-            <a:r>
-              <a:rPr lang="en-US" altLang="ko-KR" sz="2100" i="1" dirty="0">
-                <a:solidFill>
-                  <a:srgbClr val="13292A"/>
-                </a:solidFill>
-                <a:latin typeface="Cambria" pitchFamily="34" charset="0"/>
-                <a:ea typeface="Cambria" pitchFamily="34" charset="-122"/>
-                <a:cs typeface="Cambria" pitchFamily="34" charset="-120"/>
-              </a:rPr>
-              <a:t>?</a:t>
-            </a:r>
-            <a:endParaRPr lang="en-US" sz="2100" dirty="0"/>
-          </a:p>
-        </p:txBody>
-      </p:sp>
-      <p:sp>
-        <p:nvSpPr>
-          <p:cNvPr id="9" name="Text 5"/>
-          <p:cNvSpPr/>
-          <p:nvPr/>
-        </p:nvSpPr>
-        <p:spPr>
-          <a:xfrm>
-            <a:off x="1600200" y="4069080"/>
-            <a:ext cx="3657600" cy="320040"/>
-          </a:xfrm>
-          <a:prstGeom prst="rect">
-            <a:avLst/>
-          </a:prstGeom>
-          <a:noFill/>
-          <a:ln/>
-        </p:spPr>
-        <p:txBody>
-          <a:bodyPr wrap="square" lIns="0" tIns="0" rIns="0" bIns="0" rtlCol="0" anchor="ctr"/>
-          <a:lstStyle/>
-          <a:p>
-            <a:pPr marL="0" indent="0">
-              <a:buNone/>
-            </a:pPr>
-            <a:r>
-              <a:rPr lang="en-US" sz="1200" b="1" kern="0" spc="100" dirty="0" err="1">
-                <a:solidFill>
-                  <a:srgbClr val="C1440E"/>
-                </a:solidFill>
-                <a:latin typeface="Calibri" pitchFamily="34" charset="0"/>
-                <a:ea typeface="Calibri" pitchFamily="34" charset="-122"/>
-                <a:cs typeface="Calibri" pitchFamily="34" charset="-120"/>
-              </a:rPr>
-              <a:t>송파</a:t>
-            </a:r>
-            <a:r>
-              <a:rPr lang="ko-KR" altLang="en-US" sz="1200" b="1" kern="0" spc="100" dirty="0">
-                <a:solidFill>
-                  <a:srgbClr val="C1440E"/>
-                </a:solidFill>
-                <a:latin typeface="Calibri" pitchFamily="34" charset="0"/>
-                <a:ea typeface="Calibri" pitchFamily="34" charset="-122"/>
-                <a:cs typeface="Calibri" pitchFamily="34" charset="-120"/>
-              </a:rPr>
-              <a:t> </a:t>
-            </a:r>
-            <a:r>
-              <a:rPr lang="en-US" sz="1200" b="1" kern="0" spc="100" dirty="0">
-                <a:solidFill>
-                  <a:srgbClr val="C1440E"/>
-                </a:solidFill>
-                <a:latin typeface="Calibri" pitchFamily="34" charset="0"/>
-                <a:ea typeface="Calibri" pitchFamily="34" charset="-122"/>
-                <a:cs typeface="Calibri" pitchFamily="34" charset="-120"/>
-              </a:rPr>
-              <a:t>119 </a:t>
-            </a:r>
-            <a:r>
-              <a:rPr lang="en-US" sz="1200" b="1" kern="0" spc="100" dirty="0" err="1">
-                <a:solidFill>
-                  <a:srgbClr val="C1440E"/>
-                </a:solidFill>
-                <a:latin typeface="Calibri" pitchFamily="34" charset="0"/>
-                <a:ea typeface="Calibri" pitchFamily="34" charset="-122"/>
-                <a:cs typeface="Calibri" pitchFamily="34" charset="-120"/>
-              </a:rPr>
-              <a:t>구급대</a:t>
-            </a:r>
-            <a:r>
-              <a:rPr lang="en-US" sz="1200" b="1" kern="0" spc="100" dirty="0">
-                <a:solidFill>
-                  <a:srgbClr val="C1440E"/>
-                </a:solidFill>
-                <a:latin typeface="Calibri" pitchFamily="34" charset="0"/>
-                <a:ea typeface="Calibri" pitchFamily="34" charset="-122"/>
-                <a:cs typeface="Calibri" pitchFamily="34" charset="-120"/>
-              </a:rPr>
-              <a:t> </a:t>
-            </a:r>
-            <a:endParaRPr lang="en-US" sz="1200" dirty="0"/>
-          </a:p>
-        </p:txBody>
-      </p:sp>
-      <p:pic>
-        <p:nvPicPr>
-          <p:cNvPr id="4" name="오디오 3">
-            <a:extLst>
-              <a:ext uri="{FF2B5EF4-FFF2-40B4-BE49-F238E27FC236}">
-                <a16:creationId xmlns:a16="http://schemas.microsoft.com/office/drawing/2014/main" id="{112E9FD6-280C-6578-0B2C-1A8A56958D87}"/>
-              </a:ext>
-            </a:extLst>
-          </p:cNvPr>
-          <p:cNvPicPr>
-            <a:picLocks noChangeAspect="1"/>
-          </p:cNvPicPr>
-          <p:nvPr>
-            <a:audioFile r:link="rId2"/>
-            <p:extLst>
-              <p:ext uri="{DAA4B4D4-6D71-4841-9C94-3DE7FCFB9230}">
-                <p14:media xmlns:p14="http://schemas.microsoft.com/office/powerpoint/2010/main" r:embed="rId1"/>
-              </p:ext>
-            </p:extLst>
-          </p:nvPr>
-        </p:nvPicPr>
-        <p:blipFill>
-          <a:blip r:embed="rId6"/>
-          <a:stretch>
-            <a:fillRect/>
-          </a:stretch>
-        </p:blipFill>
-        <p:spPr>
-          <a:xfrm>
-            <a:off x="11226800" y="5892800"/>
-            <a:ext cx="812800" cy="812800"/>
-          </a:xfrm>
-          <a:prstGeom prst="rect">
-            <a:avLst/>
-          </a:prstGeom>
-        </p:spPr>
-      </p:pic>
-    </p:spTree>
-  </p:cSld>
-  <p:clrMapOvr>
-    <a:masterClrMapping/>
-  </p:clrMapOvr>
-  <mc:AlternateContent xmlns:mc="http://schemas.openxmlformats.org/markup-compatibility/2006">
-    <mc:Choice xmlns:p14="http://schemas.microsoft.com/office/powerpoint/2010/main" Requires="p14">
-      <p:transition spd="slow" p14:dur="2000" advTm="11212"/>
-    </mc:Choice>
-    <mc:Fallback>
-      <p:transition spd="slow" advTm="11212"/>
-    </mc:Fallback>
-  </mc:AlternateContent>
-  <p:timing>
-    <p:tnLst>
-      <p:par>
-        <p:cTn id="1" dur="indefinite" restart="never" nodeType="tmRoot">
-          <p:childTnLst>
-            <p:seq concurrent="1" nextAc="seek">
-              <p:cTn id="2" dur="indefinite" nodeType="mainSeq">
-                <p:childTnLst>
-                  <p:par>
-                    <p:cTn id="3" fill="hold">
-                      <p:stCondLst>
-                        <p:cond delay="indefinite"/>
-                        <p:cond evt="onBegin" delay="0">
-                          <p:tn val="2"/>
-                        </p:cond>
-                      </p:stCondLst>
-                      <p:childTnLst>
-                        <p:par>
-                          <p:cTn id="4" fill="hold">
-                            <p:stCondLst>
-                              <p:cond delay="0"/>
-                            </p:stCondLst>
-                            <p:childTnLst>
-                              <p:par>
-                                <p:cTn id="5" presetID="1" presetClass="mediacall" presetSubtype="0" fill="hold" nodeType="afterEffect">
-                                  <p:stCondLst>
-                                    <p:cond delay="0"/>
-                                  </p:stCondLst>
-                                  <p:childTnLst>
-                                    <p:cmd type="call" cmd="playFrom(0.0)">
-                                      <p:cBhvr>
-                                        <p:cTn id="6" dur="1" fill="hold"/>
-                                        <p:tgtEl>
-                                          <p:spTgt spid="4"/>
-                                        </p:tgtEl>
-                                      </p:cBhvr>
-                                    </p:cmd>
-                                  </p:childTnLst>
-                                </p:cTn>
-                              </p:par>
-                            </p:childTnLst>
-                          </p:cTn>
-                        </p:par>
-                      </p:childTnLst>
-                    </p:cTn>
-                  </p:par>
-                </p:childTnLst>
-              </p:cTn>
-              <p:prevCondLst>
-                <p:cond evt="onPrev" delay="0">
-                  <p:tgtEl>
-                    <p:sldTgt/>
-                  </p:tgtEl>
-                </p:cond>
-              </p:prevCondLst>
-              <p:nextCondLst>
-                <p:cond evt="onNext" delay="0">
-                  <p:tgtEl>
-                    <p:sldTgt/>
-                  </p:tgtEl>
-                </p:cond>
-              </p:nextCondLst>
-            </p:seq>
-            <p:audio isNarration="1">
-              <p:cMediaNode vol="80000" showWhenStopped="0">
-                <p:cTn id="7" fill="hold" display="0">
-                  <p:stCondLst>
-                    <p:cond delay="indefinite"/>
-                  </p:stCondLst>
-                  <p:endCondLst>
-                    <p:cond evt="onStopAudio" delay="0">
-                      <p:tgtEl>
-                        <p:sldTgt/>
-                      </p:tgtEl>
-                    </p:cond>
-                  </p:endCondLst>
-                </p:cTn>
-                <p:tgtEl>
-                  <p:spTgt spid="4"/>
                 </p:tgtEl>
               </p:cMediaNode>
             </p:audio>

</xml_diff>